<commit_message>
Refocus Pre-Lab 1 on data analysis
</commit_message>
<xml_diff>
--- a/site/docs/MIE402_Lecture02_Sampling_Jupyter_PreLab1_Fall2026.pptx
+++ b/site/docs/MIE402_Lecture02_Sampling_Jupyter_PreLab1_Fall2026.pptx
@@ -2,34 +2,34 @@
 <file path=ppt/presentation.xml><?xml version="1.0" encoding="utf-8"?>
 <p:presentation xmlns:p="http://schemas.openxmlformats.org/presentationml/2006/main">
   <p:sldMasterIdLst>
-    <p:sldMasterId xmlns:r="http://schemas.openxmlformats.org/officeDocument/2006/relationships" id="2147483648" r:id="Rc6f1c819927a41ad"/>
+    <p:sldMasterId xmlns:r="http://schemas.openxmlformats.org/officeDocument/2006/relationships" id="2147483648" r:id="Rf94b0d50e98c447a"/>
   </p:sldMasterIdLst>
   <p:notesMasterIdLst>
-    <p:notesMasterId xmlns:r="http://schemas.openxmlformats.org/officeDocument/2006/relationships" r:id="R0ebb238c09e74a9d"/>
+    <p:notesMasterId xmlns:r="http://schemas.openxmlformats.org/officeDocument/2006/relationships" r:id="Rced3ce7d23b14c21"/>
   </p:notesMasterIdLst>
   <p:sldIdLst>
-    <p:sldId xmlns:r="http://schemas.openxmlformats.org/officeDocument/2006/relationships" id="256" r:id="Radaadb01c6104683"/>
-    <p:sldId xmlns:r="http://schemas.openxmlformats.org/officeDocument/2006/relationships" id="257" r:id="Rc1209a4d3d5b4fea"/>
-    <p:sldId xmlns:r="http://schemas.openxmlformats.org/officeDocument/2006/relationships" id="258" r:id="R49affbb8000e474c"/>
-    <p:sldId xmlns:r="http://schemas.openxmlformats.org/officeDocument/2006/relationships" id="259" r:id="Rc0124a4ba499481e"/>
-    <p:sldId xmlns:r="http://schemas.openxmlformats.org/officeDocument/2006/relationships" id="260" r:id="Rb55d6bc35e7b4130"/>
-    <p:sldId xmlns:r="http://schemas.openxmlformats.org/officeDocument/2006/relationships" id="261" r:id="Rf6b32d0971a341c6"/>
-    <p:sldId xmlns:r="http://schemas.openxmlformats.org/officeDocument/2006/relationships" id="262" r:id="R5c112cef51834e6e"/>
-    <p:sldId xmlns:r="http://schemas.openxmlformats.org/officeDocument/2006/relationships" id="263" r:id="R853a128e1c7b4b08"/>
-    <p:sldId xmlns:r="http://schemas.openxmlformats.org/officeDocument/2006/relationships" id="264" r:id="Rc35eff6b62444047"/>
-    <p:sldId xmlns:r="http://schemas.openxmlformats.org/officeDocument/2006/relationships" id="265" r:id="Re4a1ad60780346e5"/>
-    <p:sldId xmlns:r="http://schemas.openxmlformats.org/officeDocument/2006/relationships" id="266" r:id="Rd0061490e58a41da"/>
-    <p:sldId xmlns:r="http://schemas.openxmlformats.org/officeDocument/2006/relationships" id="267" r:id="Rc6e182798f624eb9"/>
-    <p:sldId xmlns:r="http://schemas.openxmlformats.org/officeDocument/2006/relationships" id="268" r:id="R4c0266f8cbbf483f"/>
-    <p:sldId xmlns:r="http://schemas.openxmlformats.org/officeDocument/2006/relationships" id="269" r:id="Rba165f3c762a427d"/>
-    <p:sldId xmlns:r="http://schemas.openxmlformats.org/officeDocument/2006/relationships" id="270" r:id="R0e2a96993f414c19"/>
-    <p:sldId xmlns:r="http://schemas.openxmlformats.org/officeDocument/2006/relationships" id="271" r:id="R2fe443bd063c449e"/>
-    <p:sldId xmlns:r="http://schemas.openxmlformats.org/officeDocument/2006/relationships" id="272" r:id="Rc0c704c09b1948d6"/>
-    <p:sldId xmlns:r="http://schemas.openxmlformats.org/officeDocument/2006/relationships" id="273" r:id="R9f96d2afba3f4d5c"/>
-    <p:sldId xmlns:r="http://schemas.openxmlformats.org/officeDocument/2006/relationships" id="274" r:id="Rde534e6f4b0c4b8b"/>
-    <p:sldId xmlns:r="http://schemas.openxmlformats.org/officeDocument/2006/relationships" id="275" r:id="R3727d696c773428c"/>
-    <p:sldId xmlns:r="http://schemas.openxmlformats.org/officeDocument/2006/relationships" id="276" r:id="Rb8ebd95efb2440b2"/>
-    <p:sldId xmlns:r="http://schemas.openxmlformats.org/officeDocument/2006/relationships" id="277" r:id="Ra47f12587afb4e80"/>
+    <p:sldId xmlns:r="http://schemas.openxmlformats.org/officeDocument/2006/relationships" id="256" r:id="Ra8e08303cdcf476f"/>
+    <p:sldId xmlns:r="http://schemas.openxmlformats.org/officeDocument/2006/relationships" id="257" r:id="R0bef36d055664864"/>
+    <p:sldId xmlns:r="http://schemas.openxmlformats.org/officeDocument/2006/relationships" id="258" r:id="R9ea24af863464044"/>
+    <p:sldId xmlns:r="http://schemas.openxmlformats.org/officeDocument/2006/relationships" id="259" r:id="R38ab37ea21d74c3e"/>
+    <p:sldId xmlns:r="http://schemas.openxmlformats.org/officeDocument/2006/relationships" id="260" r:id="R92fa41d594b747c0"/>
+    <p:sldId xmlns:r="http://schemas.openxmlformats.org/officeDocument/2006/relationships" id="261" r:id="R68fa65d4fa1e4cc0"/>
+    <p:sldId xmlns:r="http://schemas.openxmlformats.org/officeDocument/2006/relationships" id="262" r:id="R0e6cebc60f444739"/>
+    <p:sldId xmlns:r="http://schemas.openxmlformats.org/officeDocument/2006/relationships" id="263" r:id="Re77b0ed97b8d41a7"/>
+    <p:sldId xmlns:r="http://schemas.openxmlformats.org/officeDocument/2006/relationships" id="264" r:id="Red5b76ca1a5e4c43"/>
+    <p:sldId xmlns:r="http://schemas.openxmlformats.org/officeDocument/2006/relationships" id="265" r:id="R896b227a6df14185"/>
+    <p:sldId xmlns:r="http://schemas.openxmlformats.org/officeDocument/2006/relationships" id="266" r:id="R6d1e465075fd405f"/>
+    <p:sldId xmlns:r="http://schemas.openxmlformats.org/officeDocument/2006/relationships" id="267" r:id="Rdcb8b2991f8c4e10"/>
+    <p:sldId xmlns:r="http://schemas.openxmlformats.org/officeDocument/2006/relationships" id="268" r:id="R70d67b5562334a44"/>
+    <p:sldId xmlns:r="http://schemas.openxmlformats.org/officeDocument/2006/relationships" id="269" r:id="R64796aa21c914221"/>
+    <p:sldId xmlns:r="http://schemas.openxmlformats.org/officeDocument/2006/relationships" id="270" r:id="Raff2149416b94032"/>
+    <p:sldId xmlns:r="http://schemas.openxmlformats.org/officeDocument/2006/relationships" id="271" r:id="Rd42c592af15a44c8"/>
+    <p:sldId xmlns:r="http://schemas.openxmlformats.org/officeDocument/2006/relationships" id="272" r:id="R18072564e0bd4bd3"/>
+    <p:sldId xmlns:r="http://schemas.openxmlformats.org/officeDocument/2006/relationships" id="273" r:id="R1c0749c5b3e14c9a"/>
+    <p:sldId xmlns:r="http://schemas.openxmlformats.org/officeDocument/2006/relationships" id="274" r:id="R2d8c55ad9e144db6"/>
+    <p:sldId xmlns:r="http://schemas.openxmlformats.org/officeDocument/2006/relationships" id="275" r:id="R06cbef156b0f452e"/>
+    <p:sldId xmlns:r="http://schemas.openxmlformats.org/officeDocument/2006/relationships" id="276" r:id="R51561a2e96dc41f9"/>
+    <p:sldId xmlns:r="http://schemas.openxmlformats.org/officeDocument/2006/relationships" id="277" r:id="Rf5088b71151c494f"/>
   </p:sldIdLst>
   <p:sldSz cx="12192000" cy="6858000"/>
   <p:notesSz cx="6858000" cy="9144000"/>
@@ -653,7 +653,7 @@
           </a:p>
           <a:p xmlns:a="http://schemas.openxmlformats.org/drawingml/2006/main">
             <a:r>
-              <a:t>Explain fs, dt, duration, and n. Point out that np.arange(n)/fs avoids accidentally including an extra endpoint. Relate longer record duration to finer FFT frequency spacing.</a:t>
+              <a:t>Explain fs, dt, duration, and n. Point out that np.arange(n)/fs avoids an extra endpoint. Relate record duration to FFT-bin spacing. Students only need to understand what the variables mean so they can interpret the output.</a:t>
             </a:r>
           </a:p>
           <a:p xmlns:a="http://schemas.openxmlformats.org/drawingml/2006/main">
@@ -923,7 +923,7 @@
           </a:p>
           <a:p xmlns:a="http://schemas.openxmlformats.org/drawingml/2006/main">
             <a:r>
-              <a:t>Trace one pass through the loop. Then explain how the same instructions repeat for each sample rate. Show that mean and RMS can stay close to theory even when the 42 Hz component aliases. This is the main reason students must inspect spectra.</a:t>
+              <a:t>Trace one pass through the prepared loop so students understand the output. Their task starts after execution: record mean and RMS, calculate samples per 42 Hz cycle, compute percent error, and compare the time histories.</a:t>
             </a:r>
           </a:p>
           <a:p xmlns:a="http://schemas.openxmlformats.org/drawingml/2006/main">
@@ -1103,7 +1103,7 @@
           </a:p>
           <a:p xmlns:a="http://schemas.openxmlformats.org/drawingml/2006/main">
             <a:r>
-              <a:t>Explain the sequence without deriving the FFT. The window reduces leakage near peaks. The coherent-gain correction restores approximate amplitude. rfft keeps the nonnegative half for a real signal. Doubling the interior bins creates a one-sided amplitude spectrum.</a:t>
+              <a:t>Explain the purpose of each prepared operation without deriving the FFT. The window reduces leakage. The coherent-gain factor corrects amplitude. rfft keeps nonnegative frequencies. Students use the output to identify peaks and test their predictions.</a:t>
             </a:r>
           </a:p>
           <a:p xmlns:a="http://schemas.openxmlformats.org/drawingml/2006/main">
@@ -1373,7 +1373,7 @@
           </a:p>
           <a:p xmlns:a="http://schemas.openxmlformats.org/drawingml/2006/main">
             <a:r>
-              <a:t>Explain grading expectations. Short answers should include numbers, units, and a reason. A statement such as the graph is wrong is incomplete. Students must identify the Nyquist limit and the false frequency.</a:t>
+              <a:t>Explain the 20-point structure. All code is prepared. Students earn credit for calculations, a completed comparison table, predictions, interpretation, and a measurement-design decision. Answers need numbers, units, and reasons.</a:t>
             </a:r>
           </a:p>
           <a:p xmlns:a="http://schemas.openxmlformats.org/drawingml/2006/main">
@@ -1463,7 +1463,7 @@
           </a:p>
           <a:p xmlns:a="http://schemas.openxmlformats.org/drawingml/2006/main">
             <a:r>
-              <a:t>Read the goals briefly. Tell students the notebook contains all required code. Their main responsibility is to run it carefully and explain the results in their own words.</a:t>
+              <a:t>Read the goals briefly. Tell students all Python code is provided. Their work is to calculate, predict, extract values from the output, compare cases, and explain the engineering meaning.</a:t>
             </a:r>
           </a:p>
           <a:p xmlns:a="http://schemas.openxmlformats.org/drawingml/2006/main">
@@ -2441,7 +2441,7 @@
   </p:cSld>
   <p:clrMap bg1="lt1" tx1="dk1" bg2="lt2" tx2="dk2" accent1="accent1" accent2="accent2" accent3="accent3" accent4="accent4" accent5="accent5" accent6="accent6" hlink="hlink" folHlink="folHlink"/>
   <p:sldLayoutIdLst>
-    <p:sldLayoutId xmlns:r="http://schemas.openxmlformats.org/officeDocument/2006/relationships" id="2147483649" r:id="R4360fbd8594e4837"/>
+    <p:sldLayoutId xmlns:r="http://schemas.openxmlformats.org/officeDocument/2006/relationships" id="2147483649" r:id="Rbb8475b5135046c1"/>
   </p:sldLayoutIdLst>
   <p:txStyles>
     <p:titleStyle>
@@ -2992,7 +2992,7 @@
           <p:cNvPr id="6" name="text">
             <a:extLst xmlns:a="http://schemas.openxmlformats.org/drawingml/2006/main">
               <a:ext uri="{FF2B5EF4-FFF2-40B4-BE49-F238E27FC236}">
-                <a16:creationId xmlns:a16="http://schemas.microsoft.com/office/drawing/2014/main" id="{49C5E1A4-71BB-4E79-B97E-5856AF934836}"/>
+                <a16:creationId xmlns:a16="http://schemas.microsoft.com/office/drawing/2014/main" id="{E6880D69-6244-4445-AE47-DC8AA021928D}"/>
               </a:ext>
             </a:extLst>
           </p:cNvPr>
@@ -3049,7 +3049,7 @@
           <p:cNvPr id="2" name="text">
             <a:extLst xmlns:a="http://schemas.openxmlformats.org/drawingml/2006/main">
               <a:ext uri="{FF2B5EF4-FFF2-40B4-BE49-F238E27FC236}">
-                <a16:creationId xmlns:a16="http://schemas.microsoft.com/office/drawing/2014/main" id="{DAB0FD75-202C-4C43-9B7D-819027B74C8B}"/>
+                <a16:creationId xmlns:a16="http://schemas.microsoft.com/office/drawing/2014/main" id="{DD799470-9C9E-4E42-B87F-285C7A169285}"/>
               </a:ext>
             </a:extLst>
           </p:cNvPr>
@@ -3129,7 +3129,7 @@
           <p:cNvPr id="3" name="text">
             <a:extLst xmlns:a="http://schemas.openxmlformats.org/drawingml/2006/main">
               <a:ext uri="{FF2B5EF4-FFF2-40B4-BE49-F238E27FC236}">
-                <a16:creationId xmlns:a16="http://schemas.microsoft.com/office/drawing/2014/main" id="{A60C4B17-7C09-4F2B-948E-04D7A9DD30A7}"/>
+                <a16:creationId xmlns:a16="http://schemas.microsoft.com/office/drawing/2014/main" id="{F3293DEF-C1A4-4397-AE1A-4A157E678CDB}"/>
               </a:ext>
             </a:extLst>
           </p:cNvPr>
@@ -3186,7 +3186,7 @@
           <p:cNvPr id="4" name="text">
             <a:extLst xmlns:a="http://schemas.openxmlformats.org/drawingml/2006/main">
               <a:ext uri="{FF2B5EF4-FFF2-40B4-BE49-F238E27FC236}">
-                <a16:creationId xmlns:a16="http://schemas.microsoft.com/office/drawing/2014/main" id="{1C0F2079-C972-4879-9FB4-63A90A3A4031}"/>
+                <a16:creationId xmlns:a16="http://schemas.microsoft.com/office/drawing/2014/main" id="{FAFCED3D-6356-4863-9BA1-A89BF67F4346}"/>
               </a:ext>
             </a:extLst>
           </p:cNvPr>
@@ -3243,7 +3243,7 @@
           <p:cNvPr id="5" name="page">
             <a:extLst xmlns:a="http://schemas.openxmlformats.org/drawingml/2006/main">
               <a:ext uri="{FF2B5EF4-FFF2-40B4-BE49-F238E27FC236}">
-                <a16:creationId xmlns:a16="http://schemas.microsoft.com/office/drawing/2014/main" id="{648AABC9-B11E-4824-AF1F-44F0289D0058}"/>
+                <a16:creationId xmlns:a16="http://schemas.microsoft.com/office/drawing/2014/main" id="{3104B6CA-D39F-4EE7-987F-FC122895C4B0}"/>
               </a:ext>
             </a:extLst>
           </p:cNvPr>
@@ -3298,7 +3298,7 @@
     </p:spTree>
     <p:extLst>
       <p:ext uri="{BB962C8B-B14F-4D97-AF65-F5344CB8AC3E}">
-        <p14:creationId xmlns:p14="http://schemas.microsoft.com/office/powerpoint/2010/main" val="1916215070"/>
+        <p14:creationId xmlns:p14="http://schemas.microsoft.com/office/powerpoint/2010/main" val="1471046099"/>
       </p:ext>
     </p:extLst>
   </p:cSld>
@@ -3329,7 +3329,7 @@
           <p:cNvPr id="8" name="course">
             <a:extLst xmlns:a="http://schemas.openxmlformats.org/drawingml/2006/main">
               <a:ext uri="{FF2B5EF4-FFF2-40B4-BE49-F238E27FC236}">
-                <a16:creationId xmlns:a16="http://schemas.microsoft.com/office/drawing/2014/main" id="{131DF16D-4D97-45C9-BB4B-395A6CE160F3}"/>
+                <a16:creationId xmlns:a16="http://schemas.microsoft.com/office/drawing/2014/main" id="{A960548D-DA3E-4BDD-A26F-4589D2EA1B82}"/>
               </a:ext>
             </a:extLst>
           </p:cNvPr>
@@ -3386,7 +3386,7 @@
           <p:cNvPr id="2" name="title">
             <a:extLst xmlns:a="http://schemas.openxmlformats.org/drawingml/2006/main">
               <a:ext uri="{FF2B5EF4-FFF2-40B4-BE49-F238E27FC236}">
-                <a16:creationId xmlns:a16="http://schemas.microsoft.com/office/drawing/2014/main" id="{3DE7FA4E-EADC-41FE-9E20-8F84DA0C7DC9}"/>
+                <a16:creationId xmlns:a16="http://schemas.microsoft.com/office/drawing/2014/main" id="{98634465-E081-4B4B-9480-A4C898790A39}"/>
               </a:ext>
             </a:extLst>
           </p:cNvPr>
@@ -3443,7 +3443,7 @@
           <p:cNvPr id="3" name="page">
             <a:extLst xmlns:a="http://schemas.openxmlformats.org/drawingml/2006/main">
               <a:ext uri="{FF2B5EF4-FFF2-40B4-BE49-F238E27FC236}">
-                <a16:creationId xmlns:a16="http://schemas.microsoft.com/office/drawing/2014/main" id="{8EDCDA1A-AC73-43BF-A4E9-226E916B61D5}"/>
+                <a16:creationId xmlns:a16="http://schemas.microsoft.com/office/drawing/2014/main" id="{DA2471D6-3CC8-43EF-B75C-036D9060F3D4}"/>
               </a:ext>
             </a:extLst>
           </p:cNvPr>
@@ -3500,7 +3500,7 @@
           <p:cNvPr id="4" name="text">
             <a:extLst xmlns:a="http://schemas.openxmlformats.org/drawingml/2006/main">
               <a:ext uri="{FF2B5EF4-FFF2-40B4-BE49-F238E27FC236}">
-                <a16:creationId xmlns:a16="http://schemas.microsoft.com/office/drawing/2014/main" id="{C79944A5-4CBB-4B40-85EE-7C916A06A59F}"/>
+                <a16:creationId xmlns:a16="http://schemas.microsoft.com/office/drawing/2014/main" id="{A3A8A3F1-A3BF-4D85-B0AD-DFD054BBB0A7}"/>
               </a:ext>
             </a:extLst>
           </p:cNvPr>
@@ -3557,7 +3557,7 @@
           <p:cNvPr id="5" name="text">
             <a:extLst xmlns:a="http://schemas.openxmlformats.org/drawingml/2006/main">
               <a:ext uri="{FF2B5EF4-FFF2-40B4-BE49-F238E27FC236}">
-                <a16:creationId xmlns:a16="http://schemas.microsoft.com/office/drawing/2014/main" id="{F072A94C-8FFA-4FB7-ADE6-19FAC71DAC70}"/>
+                <a16:creationId xmlns:a16="http://schemas.microsoft.com/office/drawing/2014/main" id="{B905F51D-EA9F-4F03-813B-8928F2C9B905}"/>
               </a:ext>
             </a:extLst>
           </p:cNvPr>
@@ -3614,7 +3614,7 @@
           <p:cNvPr id="6" name="text">
             <a:extLst xmlns:a="http://schemas.openxmlformats.org/drawingml/2006/main">
               <a:ext uri="{FF2B5EF4-FFF2-40B4-BE49-F238E27FC236}">
-                <a16:creationId xmlns:a16="http://schemas.microsoft.com/office/drawing/2014/main" id="{9F95536F-D75E-4158-8362-E8DF8F858E8E}"/>
+                <a16:creationId xmlns:a16="http://schemas.microsoft.com/office/drawing/2014/main" id="{5BD60EC4-B04D-4EB1-A45E-6B255F810049}"/>
               </a:ext>
             </a:extLst>
           </p:cNvPr>
@@ -3671,7 +3671,7 @@
           <p:cNvPr id="7" name="text">
             <a:extLst xmlns:a="http://schemas.openxmlformats.org/drawingml/2006/main">
               <a:ext uri="{FF2B5EF4-FFF2-40B4-BE49-F238E27FC236}">
-                <a16:creationId xmlns:a16="http://schemas.microsoft.com/office/drawing/2014/main" id="{5BD1FAAF-C4FE-43C6-8F1F-37A57F33896B}"/>
+                <a16:creationId xmlns:a16="http://schemas.microsoft.com/office/drawing/2014/main" id="{5AF4F533-75E3-4D88-847D-2CDB28A7D9A2}"/>
               </a:ext>
             </a:extLst>
           </p:cNvPr>
@@ -3726,7 +3726,7 @@
     </p:spTree>
     <p:extLst>
       <p:ext uri="{BB962C8B-B14F-4D97-AF65-F5344CB8AC3E}">
-        <p14:creationId xmlns:p14="http://schemas.microsoft.com/office/powerpoint/2010/main" val="1159063099"/>
+        <p14:creationId xmlns:p14="http://schemas.microsoft.com/office/powerpoint/2010/main" val="657241021"/>
       </p:ext>
     </p:extLst>
   </p:cSld>
@@ -3757,7 +3757,7 @@
           <p:cNvPr id="6" name="course">
             <a:extLst xmlns:a="http://schemas.openxmlformats.org/drawingml/2006/main">
               <a:ext uri="{FF2B5EF4-FFF2-40B4-BE49-F238E27FC236}">
-                <a16:creationId xmlns:a16="http://schemas.microsoft.com/office/drawing/2014/main" id="{242D1660-D2B9-42AD-9629-0A1453891A23}"/>
+                <a16:creationId xmlns:a16="http://schemas.microsoft.com/office/drawing/2014/main" id="{F6160E71-7991-40DD-855E-9B4300BA082F}"/>
               </a:ext>
             </a:extLst>
           </p:cNvPr>
@@ -3814,7 +3814,7 @@
           <p:cNvPr id="2" name="title">
             <a:extLst xmlns:a="http://schemas.openxmlformats.org/drawingml/2006/main">
               <a:ext uri="{FF2B5EF4-FFF2-40B4-BE49-F238E27FC236}">
-                <a16:creationId xmlns:a16="http://schemas.microsoft.com/office/drawing/2014/main" id="{66DB06D1-6354-4BDB-A383-2CB1F1DA7067}"/>
+                <a16:creationId xmlns:a16="http://schemas.microsoft.com/office/drawing/2014/main" id="{98B34B3C-B284-4B0F-810C-13FEB67AC8F2}"/>
               </a:ext>
             </a:extLst>
           </p:cNvPr>
@@ -3871,7 +3871,7 @@
           <p:cNvPr id="3" name="page">
             <a:extLst xmlns:a="http://schemas.openxmlformats.org/drawingml/2006/main">
               <a:ext uri="{FF2B5EF4-FFF2-40B4-BE49-F238E27FC236}">
-                <a16:creationId xmlns:a16="http://schemas.microsoft.com/office/drawing/2014/main" id="{EE4D3180-DDCC-4617-B8D7-F43453E8820D}"/>
+                <a16:creationId xmlns:a16="http://schemas.microsoft.com/office/drawing/2014/main" id="{645D884C-77D5-4968-A58B-FAC2DB4BB247}"/>
               </a:ext>
             </a:extLst>
           </p:cNvPr>
@@ -3928,7 +3928,7 @@
           <p:cNvPr id="4" name="code">
             <a:extLst xmlns:a="http://schemas.openxmlformats.org/drawingml/2006/main">
               <a:ext uri="{FF2B5EF4-FFF2-40B4-BE49-F238E27FC236}">
-                <a16:creationId xmlns:a16="http://schemas.microsoft.com/office/drawing/2014/main" id="{828FA193-15DE-4247-B9A6-25A33CFEA441}"/>
+                <a16:creationId xmlns:a16="http://schemas.microsoft.com/office/drawing/2014/main" id="{821F4B8B-B4A9-4E12-8A9E-9C72AA9CA828}"/>
               </a:ext>
             </a:extLst>
           </p:cNvPr>
@@ -4107,7 +4107,7 @@
           <p:cNvPr id="5" name="text">
             <a:extLst xmlns:a="http://schemas.openxmlformats.org/drawingml/2006/main">
               <a:ext uri="{FF2B5EF4-FFF2-40B4-BE49-F238E27FC236}">
-                <a16:creationId xmlns:a16="http://schemas.microsoft.com/office/drawing/2014/main" id="{2545AA3F-10BD-45BD-86AF-ACEA58A55967}"/>
+                <a16:creationId xmlns:a16="http://schemas.microsoft.com/office/drawing/2014/main" id="{97B3126D-C554-426D-B86A-E7360BD4BE92}"/>
               </a:ext>
             </a:extLst>
           </p:cNvPr>
@@ -4154,7 +4154,7 @@
                 <a:ea typeface="Calibri"/>
                 <a:cs typeface="Calibri"/>
               </a:rPr>
-              <a:t>For this one-second record, frequency-bin spacing is Δf = 1/duration = 1 Hz.</a:t>
+              <a:t>Students read these settings and analyze the resulting data. They do not modify the code.</a:t>
             </a:r>
           </a:p>
         </p:txBody>
@@ -4162,7 +4162,7 @@
     </p:spTree>
     <p:extLst>
       <p:ext uri="{BB962C8B-B14F-4D97-AF65-F5344CB8AC3E}">
-        <p14:creationId xmlns:p14="http://schemas.microsoft.com/office/powerpoint/2010/main" val="6017949"/>
+        <p14:creationId xmlns:p14="http://schemas.microsoft.com/office/powerpoint/2010/main" val="731681512"/>
       </p:ext>
     </p:extLst>
   </p:cSld>
@@ -4193,7 +4193,7 @@
           <p:cNvPr id="12" name="course">
             <a:extLst xmlns:a="http://schemas.openxmlformats.org/drawingml/2006/main">
               <a:ext uri="{FF2B5EF4-FFF2-40B4-BE49-F238E27FC236}">
-                <a16:creationId xmlns:a16="http://schemas.microsoft.com/office/drawing/2014/main" id="{0DA9422F-4508-42B1-8C3A-C33CD3F60022}"/>
+                <a16:creationId xmlns:a16="http://schemas.microsoft.com/office/drawing/2014/main" id="{14FB4301-42CF-4361-9B74-123F7FCE7AF3}"/>
               </a:ext>
             </a:extLst>
           </p:cNvPr>
@@ -4250,7 +4250,7 @@
           <p:cNvPr id="2" name="title">
             <a:extLst xmlns:a="http://schemas.openxmlformats.org/drawingml/2006/main">
               <a:ext uri="{FF2B5EF4-FFF2-40B4-BE49-F238E27FC236}">
-                <a16:creationId xmlns:a16="http://schemas.microsoft.com/office/drawing/2014/main" id="{AA162FE8-8D10-486A-BF0D-7C168CE7560A}"/>
+                <a16:creationId xmlns:a16="http://schemas.microsoft.com/office/drawing/2014/main" id="{E61E267E-1C42-4F4B-92A4-7C43F65BE173}"/>
               </a:ext>
             </a:extLst>
           </p:cNvPr>
@@ -4307,7 +4307,7 @@
           <p:cNvPr id="3" name="page">
             <a:extLst xmlns:a="http://schemas.openxmlformats.org/drawingml/2006/main">
               <a:ext uri="{FF2B5EF4-FFF2-40B4-BE49-F238E27FC236}">
-                <a16:creationId xmlns:a16="http://schemas.microsoft.com/office/drawing/2014/main" id="{4F7848E6-B129-4C43-BFED-828EA9820CFF}"/>
+                <a16:creationId xmlns:a16="http://schemas.microsoft.com/office/drawing/2014/main" id="{F32B6940-365D-4FC0-BFA5-E6D4DC44ABD0}"/>
               </a:ext>
             </a:extLst>
           </p:cNvPr>
@@ -4364,7 +4364,7 @@
           <p:cNvPr id="4" name="text">
             <a:extLst xmlns:a="http://schemas.openxmlformats.org/drawingml/2006/main">
               <a:ext uri="{FF2B5EF4-FFF2-40B4-BE49-F238E27FC236}">
-                <a16:creationId xmlns:a16="http://schemas.microsoft.com/office/drawing/2014/main" id="{7BADDEBA-CB21-45A9-9B4C-E3C3898B4B19}"/>
+                <a16:creationId xmlns:a16="http://schemas.microsoft.com/office/drawing/2014/main" id="{A84237AE-5413-455E-86AA-99FBB6EE1332}"/>
               </a:ext>
             </a:extLst>
           </p:cNvPr>
@@ -4421,7 +4421,7 @@
           <p:cNvPr id="5" name="text">
             <a:extLst xmlns:a="http://schemas.openxmlformats.org/drawingml/2006/main">
               <a:ext uri="{FF2B5EF4-FFF2-40B4-BE49-F238E27FC236}">
-                <a16:creationId xmlns:a16="http://schemas.microsoft.com/office/drawing/2014/main" id="{1C3BF778-E22D-4FDE-A8C0-FEEBDADF2377}"/>
+                <a16:creationId xmlns:a16="http://schemas.microsoft.com/office/drawing/2014/main" id="{338B8A29-1878-4BE5-AEAD-4DAADE0E30BE}"/>
               </a:ext>
             </a:extLst>
           </p:cNvPr>
@@ -4478,7 +4478,7 @@
           <p:cNvPr id="6" name="text">
             <a:extLst xmlns:a="http://schemas.openxmlformats.org/drawingml/2006/main">
               <a:ext uri="{FF2B5EF4-FFF2-40B4-BE49-F238E27FC236}">
-                <a16:creationId xmlns:a16="http://schemas.microsoft.com/office/drawing/2014/main" id="{154AD827-DEF8-4733-8CBB-96DFA2A8AC64}"/>
+                <a16:creationId xmlns:a16="http://schemas.microsoft.com/office/drawing/2014/main" id="{77E0E44E-4CC8-4D27-A252-109EE16CA3D7}"/>
               </a:ext>
             </a:extLst>
           </p:cNvPr>
@@ -4535,7 +4535,7 @@
           <p:cNvPr id="7" name="text">
             <a:extLst xmlns:a="http://schemas.openxmlformats.org/drawingml/2006/main">
               <a:ext uri="{FF2B5EF4-FFF2-40B4-BE49-F238E27FC236}">
-                <a16:creationId xmlns:a16="http://schemas.microsoft.com/office/drawing/2014/main" id="{3D2F1D7F-3823-430C-8313-6BBEDBFE5592}"/>
+                <a16:creationId xmlns:a16="http://schemas.microsoft.com/office/drawing/2014/main" id="{A50550A6-12D0-43F8-AD68-13912BD70987}"/>
               </a:ext>
             </a:extLst>
           </p:cNvPr>
@@ -4592,7 +4592,7 @@
           <p:cNvPr id="8" name="text">
             <a:extLst xmlns:a="http://schemas.openxmlformats.org/drawingml/2006/main">
               <a:ext uri="{FF2B5EF4-FFF2-40B4-BE49-F238E27FC236}">
-                <a16:creationId xmlns:a16="http://schemas.microsoft.com/office/drawing/2014/main" id="{EE887525-91BC-4706-9669-A77604E129CA}"/>
+                <a16:creationId xmlns:a16="http://schemas.microsoft.com/office/drawing/2014/main" id="{9F44123E-AB17-42DA-BADC-1484357263F7}"/>
               </a:ext>
             </a:extLst>
           </p:cNvPr>
@@ -4649,7 +4649,7 @@
           <p:cNvPr id="9" name="text">
             <a:extLst xmlns:a="http://schemas.openxmlformats.org/drawingml/2006/main">
               <a:ext uri="{FF2B5EF4-FFF2-40B4-BE49-F238E27FC236}">
-                <a16:creationId xmlns:a16="http://schemas.microsoft.com/office/drawing/2014/main" id="{20CD67EC-F0B8-49D3-B4A3-2EBEA91D72B6}"/>
+                <a16:creationId xmlns:a16="http://schemas.microsoft.com/office/drawing/2014/main" id="{56F12702-43C3-47A1-8701-1618B68533C5}"/>
               </a:ext>
             </a:extLst>
           </p:cNvPr>
@@ -4706,7 +4706,7 @@
           <p:cNvPr id="10" name="text">
             <a:extLst xmlns:a="http://schemas.openxmlformats.org/drawingml/2006/main">
               <a:ext uri="{FF2B5EF4-FFF2-40B4-BE49-F238E27FC236}">
-                <a16:creationId xmlns:a16="http://schemas.microsoft.com/office/drawing/2014/main" id="{E49EBCA4-04B2-4423-973E-A1A9E19AF0CE}"/>
+                <a16:creationId xmlns:a16="http://schemas.microsoft.com/office/drawing/2014/main" id="{C8A58CCA-8D98-4FD8-AF02-7F0035273EAE}"/>
               </a:ext>
             </a:extLst>
           </p:cNvPr>
@@ -4763,7 +4763,7 @@
           <p:cNvPr id="11" name="text">
             <a:extLst xmlns:a="http://schemas.openxmlformats.org/drawingml/2006/main">
               <a:ext uri="{FF2B5EF4-FFF2-40B4-BE49-F238E27FC236}">
-                <a16:creationId xmlns:a16="http://schemas.microsoft.com/office/drawing/2014/main" id="{B208750D-3E3D-46A4-A6D3-8D88944634D1}"/>
+                <a16:creationId xmlns:a16="http://schemas.microsoft.com/office/drawing/2014/main" id="{11D191EA-FD29-4255-8246-282DD7C101E1}"/>
               </a:ext>
             </a:extLst>
           </p:cNvPr>
@@ -4818,7 +4818,7 @@
     </p:spTree>
     <p:extLst>
       <p:ext uri="{BB962C8B-B14F-4D97-AF65-F5344CB8AC3E}">
-        <p14:creationId xmlns:p14="http://schemas.microsoft.com/office/powerpoint/2010/main" val="1991876967"/>
+        <p14:creationId xmlns:p14="http://schemas.microsoft.com/office/powerpoint/2010/main" val="743460673"/>
       </p:ext>
     </p:extLst>
   </p:cSld>
@@ -4849,7 +4849,7 @@
           <p:cNvPr id="12" name="course">
             <a:extLst xmlns:a="http://schemas.openxmlformats.org/drawingml/2006/main">
               <a:ext uri="{FF2B5EF4-FFF2-40B4-BE49-F238E27FC236}">
-                <a16:creationId xmlns:a16="http://schemas.microsoft.com/office/drawing/2014/main" id="{5BC9B808-7B60-4557-985D-1E6EA4AC1F80}"/>
+                <a16:creationId xmlns:a16="http://schemas.microsoft.com/office/drawing/2014/main" id="{292D0884-7B20-465C-BA3F-723D9123B17A}"/>
               </a:ext>
             </a:extLst>
           </p:cNvPr>
@@ -4906,7 +4906,7 @@
           <p:cNvPr id="2" name="title">
             <a:extLst xmlns:a="http://schemas.openxmlformats.org/drawingml/2006/main">
               <a:ext uri="{FF2B5EF4-FFF2-40B4-BE49-F238E27FC236}">
-                <a16:creationId xmlns:a16="http://schemas.microsoft.com/office/drawing/2014/main" id="{C12F5549-9034-4AC4-90AC-943F22B83531}"/>
+                <a16:creationId xmlns:a16="http://schemas.microsoft.com/office/drawing/2014/main" id="{12F490D6-D0BD-414A-9A99-493D7B744C4E}"/>
               </a:ext>
             </a:extLst>
           </p:cNvPr>
@@ -4963,7 +4963,7 @@
           <p:cNvPr id="3" name="page">
             <a:extLst xmlns:a="http://schemas.openxmlformats.org/drawingml/2006/main">
               <a:ext uri="{FF2B5EF4-FFF2-40B4-BE49-F238E27FC236}">
-                <a16:creationId xmlns:a16="http://schemas.microsoft.com/office/drawing/2014/main" id="{F4C1D242-BBD1-450C-A2DB-87161D1C217E}"/>
+                <a16:creationId xmlns:a16="http://schemas.microsoft.com/office/drawing/2014/main" id="{04C64AAB-0C62-4C31-9601-501E924861DA}"/>
               </a:ext>
             </a:extLst>
           </p:cNvPr>
@@ -5020,7 +5020,7 @@
           <p:cNvPr id="4" name="text">
             <a:extLst xmlns:a="http://schemas.openxmlformats.org/drawingml/2006/main">
               <a:ext uri="{FF2B5EF4-FFF2-40B4-BE49-F238E27FC236}">
-                <a16:creationId xmlns:a16="http://schemas.microsoft.com/office/drawing/2014/main" id="{B62687E5-4071-49D6-972B-C2EEDBEE0A2F}"/>
+                <a16:creationId xmlns:a16="http://schemas.microsoft.com/office/drawing/2014/main" id="{FC27E336-6228-41E1-8C29-487523370674}"/>
               </a:ext>
             </a:extLst>
           </p:cNvPr>
@@ -5077,7 +5077,7 @@
           <p:cNvPr id="5" name="text">
             <a:extLst xmlns:a="http://schemas.openxmlformats.org/drawingml/2006/main">
               <a:ext uri="{FF2B5EF4-FFF2-40B4-BE49-F238E27FC236}">
-                <a16:creationId xmlns:a16="http://schemas.microsoft.com/office/drawing/2014/main" id="{F3A5B04E-8A40-42C1-8FC3-1C8468831825}"/>
+                <a16:creationId xmlns:a16="http://schemas.microsoft.com/office/drawing/2014/main" id="{97B9CBDD-79CB-4862-BA40-453CE8BC947F}"/>
               </a:ext>
             </a:extLst>
           </p:cNvPr>
@@ -5134,7 +5134,7 @@
           <p:cNvPr id="6" name="text">
             <a:extLst xmlns:a="http://schemas.openxmlformats.org/drawingml/2006/main">
               <a:ext uri="{FF2B5EF4-FFF2-40B4-BE49-F238E27FC236}">
-                <a16:creationId xmlns:a16="http://schemas.microsoft.com/office/drawing/2014/main" id="{9F1C8410-67F3-4763-80B4-16346D3F7689}"/>
+                <a16:creationId xmlns:a16="http://schemas.microsoft.com/office/drawing/2014/main" id="{BFC90542-5624-47E6-96CE-BEF4E8C9FF74}"/>
               </a:ext>
             </a:extLst>
           </p:cNvPr>
@@ -5191,7 +5191,7 @@
           <p:cNvPr id="7" name="text">
             <a:extLst xmlns:a="http://schemas.openxmlformats.org/drawingml/2006/main">
               <a:ext uri="{FF2B5EF4-FFF2-40B4-BE49-F238E27FC236}">
-                <a16:creationId xmlns:a16="http://schemas.microsoft.com/office/drawing/2014/main" id="{A2C401AC-4539-4339-8535-5CDFF64E8DB5}"/>
+                <a16:creationId xmlns:a16="http://schemas.microsoft.com/office/drawing/2014/main" id="{86CC2515-68DA-4839-852E-7B19EE2D37D6}"/>
               </a:ext>
             </a:extLst>
           </p:cNvPr>
@@ -5248,7 +5248,7 @@
           <p:cNvPr id="8" name="text">
             <a:extLst xmlns:a="http://schemas.openxmlformats.org/drawingml/2006/main">
               <a:ext uri="{FF2B5EF4-FFF2-40B4-BE49-F238E27FC236}">
-                <a16:creationId xmlns:a16="http://schemas.microsoft.com/office/drawing/2014/main" id="{DDA2B895-B081-467B-92DA-FC9C4C2D2D04}"/>
+                <a16:creationId xmlns:a16="http://schemas.microsoft.com/office/drawing/2014/main" id="{691BCA60-755D-4BD7-80AA-7ABB229C2EF6}"/>
               </a:ext>
             </a:extLst>
           </p:cNvPr>
@@ -5305,7 +5305,7 @@
           <p:cNvPr id="9" name="text">
             <a:extLst xmlns:a="http://schemas.openxmlformats.org/drawingml/2006/main">
               <a:ext uri="{FF2B5EF4-FFF2-40B4-BE49-F238E27FC236}">
-                <a16:creationId xmlns:a16="http://schemas.microsoft.com/office/drawing/2014/main" id="{455A951C-F4E0-48BF-B0A4-E56B8EBC7B0F}"/>
+                <a16:creationId xmlns:a16="http://schemas.microsoft.com/office/drawing/2014/main" id="{5EA9DDD7-A8AC-4028-8E83-BDB11B75DA02}"/>
               </a:ext>
             </a:extLst>
           </p:cNvPr>
@@ -5362,7 +5362,7 @@
           <p:cNvPr id="10" name="text">
             <a:extLst xmlns:a="http://schemas.openxmlformats.org/drawingml/2006/main">
               <a:ext uri="{FF2B5EF4-FFF2-40B4-BE49-F238E27FC236}">
-                <a16:creationId xmlns:a16="http://schemas.microsoft.com/office/drawing/2014/main" id="{15E96D72-5563-4FFC-A6FD-9E33DDBB9367}"/>
+                <a16:creationId xmlns:a16="http://schemas.microsoft.com/office/drawing/2014/main" id="{1442B973-3935-4CFD-BCE8-5D7427E0DB34}"/>
               </a:ext>
             </a:extLst>
           </p:cNvPr>
@@ -5419,7 +5419,7 @@
           <p:cNvPr id="11" name="text">
             <a:extLst xmlns:a="http://schemas.openxmlformats.org/drawingml/2006/main">
               <a:ext uri="{FF2B5EF4-FFF2-40B4-BE49-F238E27FC236}">
-                <a16:creationId xmlns:a16="http://schemas.microsoft.com/office/drawing/2014/main" id="{924A929C-2849-4380-8A9C-FA9C7659E3D3}"/>
+                <a16:creationId xmlns:a16="http://schemas.microsoft.com/office/drawing/2014/main" id="{0D3365B4-54E3-48C5-AE62-1B1BC9D60141}"/>
               </a:ext>
             </a:extLst>
           </p:cNvPr>
@@ -5474,7 +5474,7 @@
     </p:spTree>
     <p:extLst>
       <p:ext uri="{BB962C8B-B14F-4D97-AF65-F5344CB8AC3E}">
-        <p14:creationId xmlns:p14="http://schemas.microsoft.com/office/powerpoint/2010/main" val="436682457"/>
+        <p14:creationId xmlns:p14="http://schemas.microsoft.com/office/powerpoint/2010/main" val="1332020624"/>
       </p:ext>
     </p:extLst>
   </p:cSld>
@@ -5505,7 +5505,7 @@
           <p:cNvPr id="6" name="course">
             <a:extLst xmlns:a="http://schemas.openxmlformats.org/drawingml/2006/main">
               <a:ext uri="{FF2B5EF4-FFF2-40B4-BE49-F238E27FC236}">
-                <a16:creationId xmlns:a16="http://schemas.microsoft.com/office/drawing/2014/main" id="{83E8ECE1-130E-439F-89F6-F2BA2954725F}"/>
+                <a16:creationId xmlns:a16="http://schemas.microsoft.com/office/drawing/2014/main" id="{2BBDEB80-0E70-4B69-8875-372442861745}"/>
               </a:ext>
             </a:extLst>
           </p:cNvPr>
@@ -5562,7 +5562,7 @@
           <p:cNvPr id="2" name="title">
             <a:extLst xmlns:a="http://schemas.openxmlformats.org/drawingml/2006/main">
               <a:ext uri="{FF2B5EF4-FFF2-40B4-BE49-F238E27FC236}">
-                <a16:creationId xmlns:a16="http://schemas.microsoft.com/office/drawing/2014/main" id="{A099C832-92E5-467C-AD37-2DDBF864BC94}"/>
+                <a16:creationId xmlns:a16="http://schemas.microsoft.com/office/drawing/2014/main" id="{F7AEEAD2-CAD2-43F0-98F6-FD7D39B544E9}"/>
               </a:ext>
             </a:extLst>
           </p:cNvPr>
@@ -5609,7 +5609,7 @@
                 <a:ea typeface="Calibri"/>
                 <a:cs typeface="Calibri"/>
               </a:rPr>
-              <a:t>The sampling loop</a:t>
+              <a:t>The prepared sampling analysis</a:t>
             </a:r>
           </a:p>
         </p:txBody>
@@ -5619,7 +5619,7 @@
           <p:cNvPr id="3" name="page">
             <a:extLst xmlns:a="http://schemas.openxmlformats.org/drawingml/2006/main">
               <a:ext uri="{FF2B5EF4-FFF2-40B4-BE49-F238E27FC236}">
-                <a16:creationId xmlns:a16="http://schemas.microsoft.com/office/drawing/2014/main" id="{62D209F9-AFE6-4357-9F0D-98FC02E35EC7}"/>
+                <a16:creationId xmlns:a16="http://schemas.microsoft.com/office/drawing/2014/main" id="{9C61FBAE-11D2-426B-A730-ABB9B5A4E5B5}"/>
               </a:ext>
             </a:extLst>
           </p:cNvPr>
@@ -5676,7 +5676,7 @@
           <p:cNvPr id="4" name="code">
             <a:extLst xmlns:a="http://schemas.openxmlformats.org/drawingml/2006/main">
               <a:ext uri="{FF2B5EF4-FFF2-40B4-BE49-F238E27FC236}">
-                <a16:creationId xmlns:a16="http://schemas.microsoft.com/office/drawing/2014/main" id="{417EBCB4-6984-40BD-8E39-AD88C4C23B41}"/>
+                <a16:creationId xmlns:a16="http://schemas.microsoft.com/office/drawing/2014/main" id="{870D6C95-8C2D-47F2-BC60-6815291CDDA9}"/>
               </a:ext>
             </a:extLst>
           </p:cNvPr>
@@ -5725,7 +5725,7 @@
                 <a:ea typeface="Consolas"/>
                 <a:cs typeface="Consolas"/>
               </a:rPr>
-              <a:t>sample_rates = [336.0, 126.0, 72.0, 48.0]</a:t>
+              <a:t>for fs in sample_rates:</a:t>
             </a:r>
           </a:p>
           <a:p xmlns:a="http://schemas.openxmlformats.org/drawingml/2006/main">
@@ -5748,12 +5748,7 @@
                 <a:ea typeface="Consolas"/>
                 <a:cs typeface="Consolas"/>
               </a:rPr>
-              <a:t>records = {}</a:t>
-            </a:r>
-          </a:p>
-          <a:p xmlns:a="http://schemas.openxmlformats.org/drawingml/2006/main">
-            <a:r>
-              <a:t/>
+              <a:t>    n = int(round(duration*fs))</a:t>
             </a:r>
           </a:p>
           <a:p xmlns:a="http://schemas.openxmlformats.org/drawingml/2006/main">
@@ -5776,7 +5771,7 @@
                 <a:ea typeface="Consolas"/>
                 <a:cs typeface="Consolas"/>
               </a:rPr>
-              <a:t>for fs in sample_rates:</a:t>
+              <a:t>    t = np.arange(n)/fs</a:t>
             </a:r>
           </a:p>
           <a:p xmlns:a="http://schemas.openxmlformats.org/drawingml/2006/main">
@@ -5799,7 +5794,7 @@
                 <a:ea typeface="Consolas"/>
                 <a:cs typeface="Consolas"/>
               </a:rPr>
-              <a:t>    n = int(round(duration*fs))</a:t>
+              <a:t>    x = signal(t)</a:t>
             </a:r>
           </a:p>
           <a:p xmlns:a="http://schemas.openxmlformats.org/drawingml/2006/main">
@@ -5822,7 +5817,7 @@
                 <a:ea typeface="Consolas"/>
                 <a:cs typeface="Consolas"/>
               </a:rPr>
-              <a:t>    t = np.arange(n)/fs</a:t>
+              <a:t>    records[fs] = (t, x)</a:t>
             </a:r>
           </a:p>
           <a:p xmlns:a="http://schemas.openxmlformats.org/drawingml/2006/main">
@@ -5845,7 +5840,7 @@
                 <a:ea typeface="Consolas"/>
                 <a:cs typeface="Consolas"/>
               </a:rPr>
-              <a:t>    x = signal(t)</a:t>
+              <a:t>    sample_mean, sample_rms = mean_and_rms(x)</a:t>
             </a:r>
           </a:p>
           <a:p xmlns:a="http://schemas.openxmlformats.org/drawingml/2006/main">
@@ -5868,30 +5863,7 @@
                 <a:ea typeface="Consolas"/>
                 <a:cs typeface="Consolas"/>
               </a:rPr>
-              <a:t>    records[fs] = (t, x)</a:t>
-            </a:r>
-          </a:p>
-          <a:p xmlns:a="http://schemas.openxmlformats.org/drawingml/2006/main">
-            <a:pPr>
-              <a:defRPr sz="1725" b="0">
-                <a:solidFill>
-                  <a:srgbClr val="202124"/>
-                </a:solidFill>
-                <a:latin typeface="Consolas"/>
-                <a:ea typeface="Consolas"/>
-                <a:cs typeface="Consolas"/>
-              </a:defRPr>
-            </a:pPr>
-            <a:r>
-              <a:rPr sz="1725" b="0">
-                <a:solidFill>
-                  <a:srgbClr val="202124"/>
-                </a:solidFill>
-                <a:latin typeface="Consolas"/>
-                <a:ea typeface="Consolas"/>
-                <a:cs typeface="Consolas"/>
-              </a:rPr>
-              <a:t>    print(fs, np.mean(x), np.sqrt(np.mean(x**2)))</a:t>
+              <a:t>    print(fs, sample_mean, sample_rms)</a:t>
             </a:r>
           </a:p>
         </p:txBody>
@@ -5901,7 +5873,7 @@
           <p:cNvPr id="5" name="text">
             <a:extLst xmlns:a="http://schemas.openxmlformats.org/drawingml/2006/main">
               <a:ext uri="{FF2B5EF4-FFF2-40B4-BE49-F238E27FC236}">
-                <a16:creationId xmlns:a16="http://schemas.microsoft.com/office/drawing/2014/main" id="{3BF868E7-75E0-4BAD-9574-208121B3A26D}"/>
+                <a16:creationId xmlns:a16="http://schemas.microsoft.com/office/drawing/2014/main" id="{ED48EA8B-3158-4D81-9CC8-C3B452D5668F}"/>
               </a:ext>
             </a:extLst>
           </p:cNvPr>
@@ -5948,7 +5920,7 @@
                 <a:ea typeface="Calibri"/>
                 <a:cs typeface="Calibri"/>
               </a:rPr>
-              <a:t>A dictionary stores each time array and sampled signal under its sample rate.</a:t>
+              <a:t>Students transfer the printed values to an analysis table and calculate RMS percent error.</a:t>
             </a:r>
           </a:p>
         </p:txBody>
@@ -5956,7 +5928,7 @@
     </p:spTree>
     <p:extLst>
       <p:ext uri="{BB962C8B-B14F-4D97-AF65-F5344CB8AC3E}">
-        <p14:creationId xmlns:p14="http://schemas.microsoft.com/office/powerpoint/2010/main" val="406124264"/>
+        <p14:creationId xmlns:p14="http://schemas.microsoft.com/office/powerpoint/2010/main" val="1643068932"/>
       </p:ext>
     </p:extLst>
   </p:cSld>
@@ -5987,7 +5959,7 @@
           <p:cNvPr id="12" name="course">
             <a:extLst xmlns:a="http://schemas.openxmlformats.org/drawingml/2006/main">
               <a:ext uri="{FF2B5EF4-FFF2-40B4-BE49-F238E27FC236}">
-                <a16:creationId xmlns:a16="http://schemas.microsoft.com/office/drawing/2014/main" id="{67ADC500-E4CE-4DDF-920F-6BD7D3CD040D}"/>
+                <a16:creationId xmlns:a16="http://schemas.microsoft.com/office/drawing/2014/main" id="{F60C2681-C659-4AD6-A3D5-D134EBC0FB12}"/>
               </a:ext>
             </a:extLst>
           </p:cNvPr>
@@ -6044,7 +6016,7 @@
           <p:cNvPr id="2" name="title">
             <a:extLst xmlns:a="http://schemas.openxmlformats.org/drawingml/2006/main">
               <a:ext uri="{FF2B5EF4-FFF2-40B4-BE49-F238E27FC236}">
-                <a16:creationId xmlns:a16="http://schemas.microsoft.com/office/drawing/2014/main" id="{B8625BBF-B74F-44FC-9DD3-BD95E7EE3C0D}"/>
+                <a16:creationId xmlns:a16="http://schemas.microsoft.com/office/drawing/2014/main" id="{C86B01E4-6BAC-43FC-BD69-24223508D644}"/>
               </a:ext>
             </a:extLst>
           </p:cNvPr>
@@ -6101,7 +6073,7 @@
           <p:cNvPr id="3" name="page">
             <a:extLst xmlns:a="http://schemas.openxmlformats.org/drawingml/2006/main">
               <a:ext uri="{FF2B5EF4-FFF2-40B4-BE49-F238E27FC236}">
-                <a16:creationId xmlns:a16="http://schemas.microsoft.com/office/drawing/2014/main" id="{2C905156-2B2B-4741-937D-8ADE71A8F709}"/>
+                <a16:creationId xmlns:a16="http://schemas.microsoft.com/office/drawing/2014/main" id="{F5711892-6845-40A1-8348-3EE4CF1A9B3E}"/>
               </a:ext>
             </a:extLst>
           </p:cNvPr>
@@ -6158,7 +6130,7 @@
           <p:cNvPr id="4" name="text">
             <a:extLst xmlns:a="http://schemas.openxmlformats.org/drawingml/2006/main">
               <a:ext uri="{FF2B5EF4-FFF2-40B4-BE49-F238E27FC236}">
-                <a16:creationId xmlns:a16="http://schemas.microsoft.com/office/drawing/2014/main" id="{5049C7B5-E449-42D8-BB75-8474657D2023}"/>
+                <a16:creationId xmlns:a16="http://schemas.microsoft.com/office/drawing/2014/main" id="{D8B13FF0-FBB6-462F-84D4-A30817EA057B}"/>
               </a:ext>
             </a:extLst>
           </p:cNvPr>
@@ -6215,7 +6187,7 @@
           <p:cNvPr id="5" name="text">
             <a:extLst xmlns:a="http://schemas.openxmlformats.org/drawingml/2006/main">
               <a:ext uri="{FF2B5EF4-FFF2-40B4-BE49-F238E27FC236}">
-                <a16:creationId xmlns:a16="http://schemas.microsoft.com/office/drawing/2014/main" id="{8F13144A-34CB-4367-9265-525B8F85BF3C}"/>
+                <a16:creationId xmlns:a16="http://schemas.microsoft.com/office/drawing/2014/main" id="{62416061-3C3E-43D4-B474-DBBB8976EABA}"/>
               </a:ext>
             </a:extLst>
           </p:cNvPr>
@@ -6272,7 +6244,7 @@
           <p:cNvPr id="6" name="text">
             <a:extLst xmlns:a="http://schemas.openxmlformats.org/drawingml/2006/main">
               <a:ext uri="{FF2B5EF4-FFF2-40B4-BE49-F238E27FC236}">
-                <a16:creationId xmlns:a16="http://schemas.microsoft.com/office/drawing/2014/main" id="{87D63D5C-4970-486C-973D-6F3811BED9D8}"/>
+                <a16:creationId xmlns:a16="http://schemas.microsoft.com/office/drawing/2014/main" id="{83C180B5-B289-4A74-B5F8-C39FCD76CA13}"/>
               </a:ext>
             </a:extLst>
           </p:cNvPr>
@@ -6329,7 +6301,7 @@
           <p:cNvPr id="7" name="text">
             <a:extLst xmlns:a="http://schemas.openxmlformats.org/drawingml/2006/main">
               <a:ext uri="{FF2B5EF4-FFF2-40B4-BE49-F238E27FC236}">
-                <a16:creationId xmlns:a16="http://schemas.microsoft.com/office/drawing/2014/main" id="{EEC9DC31-6B35-4E4A-888A-4DED7579FEDA}"/>
+                <a16:creationId xmlns:a16="http://schemas.microsoft.com/office/drawing/2014/main" id="{E6662309-D6C4-46EA-A497-DDB32CBA7532}"/>
               </a:ext>
             </a:extLst>
           </p:cNvPr>
@@ -6386,7 +6358,7 @@
           <p:cNvPr id="8" name="text">
             <a:extLst xmlns:a="http://schemas.openxmlformats.org/drawingml/2006/main">
               <a:ext uri="{FF2B5EF4-FFF2-40B4-BE49-F238E27FC236}">
-                <a16:creationId xmlns:a16="http://schemas.microsoft.com/office/drawing/2014/main" id="{6B8FDD6B-BE1F-42E8-835C-FD63ABAEB10E}"/>
+                <a16:creationId xmlns:a16="http://schemas.microsoft.com/office/drawing/2014/main" id="{E0BF97C9-A033-445B-BCE9-728B14194AB9}"/>
               </a:ext>
             </a:extLst>
           </p:cNvPr>
@@ -6443,7 +6415,7 @@
           <p:cNvPr id="9" name="text">
             <a:extLst xmlns:a="http://schemas.openxmlformats.org/drawingml/2006/main">
               <a:ext uri="{FF2B5EF4-FFF2-40B4-BE49-F238E27FC236}">
-                <a16:creationId xmlns:a16="http://schemas.microsoft.com/office/drawing/2014/main" id="{22D68FA4-A7D3-4CD9-BCD7-FCB775919761}"/>
+                <a16:creationId xmlns:a16="http://schemas.microsoft.com/office/drawing/2014/main" id="{DABAA696-116A-4F03-AFE1-33854F8F2ECD}"/>
               </a:ext>
             </a:extLst>
           </p:cNvPr>
@@ -6500,7 +6472,7 @@
           <p:cNvPr id="10" name="text">
             <a:extLst xmlns:a="http://schemas.openxmlformats.org/drawingml/2006/main">
               <a:ext uri="{FF2B5EF4-FFF2-40B4-BE49-F238E27FC236}">
-                <a16:creationId xmlns:a16="http://schemas.microsoft.com/office/drawing/2014/main" id="{EEAA3085-1E76-4225-BD49-394E62B8FB99}"/>
+                <a16:creationId xmlns:a16="http://schemas.microsoft.com/office/drawing/2014/main" id="{E8F09A39-9C1B-4611-9762-A4A0BE7C4231}"/>
               </a:ext>
             </a:extLst>
           </p:cNvPr>
@@ -6557,7 +6529,7 @@
           <p:cNvPr id="11" name="text">
             <a:extLst xmlns:a="http://schemas.openxmlformats.org/drawingml/2006/main">
               <a:ext uri="{FF2B5EF4-FFF2-40B4-BE49-F238E27FC236}">
-                <a16:creationId xmlns:a16="http://schemas.microsoft.com/office/drawing/2014/main" id="{15C92CFC-9CC8-4379-ADE5-8BB59764AACC}"/>
+                <a16:creationId xmlns:a16="http://schemas.microsoft.com/office/drawing/2014/main" id="{CF11160B-609C-4502-A322-8D35BEDF8816}"/>
               </a:ext>
             </a:extLst>
           </p:cNvPr>
@@ -6612,7 +6584,7 @@
     </p:spTree>
     <p:extLst>
       <p:ext uri="{BB962C8B-B14F-4D97-AF65-F5344CB8AC3E}">
-        <p14:creationId xmlns:p14="http://schemas.microsoft.com/office/powerpoint/2010/main" val="1028568190"/>
+        <p14:creationId xmlns:p14="http://schemas.microsoft.com/office/powerpoint/2010/main" val="1606445025"/>
       </p:ext>
     </p:extLst>
   </p:cSld>
@@ -6643,7 +6615,7 @@
           <p:cNvPr id="6" name="course">
             <a:extLst xmlns:a="http://schemas.openxmlformats.org/drawingml/2006/main">
               <a:ext uri="{FF2B5EF4-FFF2-40B4-BE49-F238E27FC236}">
-                <a16:creationId xmlns:a16="http://schemas.microsoft.com/office/drawing/2014/main" id="{B2FAB313-7E17-47AC-9161-0FD55D596880}"/>
+                <a16:creationId xmlns:a16="http://schemas.microsoft.com/office/drawing/2014/main" id="{539FFB4A-2E4E-46C2-85E5-C929E0EE89B3}"/>
               </a:ext>
             </a:extLst>
           </p:cNvPr>
@@ -6700,7 +6672,7 @@
           <p:cNvPr id="2" name="title">
             <a:extLst xmlns:a="http://schemas.openxmlformats.org/drawingml/2006/main">
               <a:ext uri="{FF2B5EF4-FFF2-40B4-BE49-F238E27FC236}">
-                <a16:creationId xmlns:a16="http://schemas.microsoft.com/office/drawing/2014/main" id="{1FA4C7A3-CB02-4E39-B2D3-3A09A164067D}"/>
+                <a16:creationId xmlns:a16="http://schemas.microsoft.com/office/drawing/2014/main" id="{28BC5523-706B-4CE9-B800-32F342EAF038}"/>
               </a:ext>
             </a:extLst>
           </p:cNvPr>
@@ -6747,7 +6719,7 @@
                 <a:ea typeface="Calibri"/>
                 <a:cs typeface="Calibri"/>
               </a:rPr>
-              <a:t>One-sided FFT calculation</a:t>
+              <a:t>The prepared FFT analysis</a:t>
             </a:r>
           </a:p>
         </p:txBody>
@@ -6757,7 +6729,7 @@
           <p:cNvPr id="3" name="page">
             <a:extLst xmlns:a="http://schemas.openxmlformats.org/drawingml/2006/main">
               <a:ext uri="{FF2B5EF4-FFF2-40B4-BE49-F238E27FC236}">
-                <a16:creationId xmlns:a16="http://schemas.microsoft.com/office/drawing/2014/main" id="{AF63A08B-78AC-406F-9F6D-96D73866FB6A}"/>
+                <a16:creationId xmlns:a16="http://schemas.microsoft.com/office/drawing/2014/main" id="{D78AD75C-1216-4209-90E4-3D7F356A7295}"/>
               </a:ext>
             </a:extLst>
           </p:cNvPr>
@@ -6814,7 +6786,7 @@
           <p:cNvPr id="4" name="code">
             <a:extLst xmlns:a="http://schemas.openxmlformats.org/drawingml/2006/main">
               <a:ext uri="{FF2B5EF4-FFF2-40B4-BE49-F238E27FC236}">
-                <a16:creationId xmlns:a16="http://schemas.microsoft.com/office/drawing/2014/main" id="{E00CC5A0-41B6-4B87-9A60-C5D8CC720A4C}"/>
+                <a16:creationId xmlns:a16="http://schemas.microsoft.com/office/drawing/2014/main" id="{91E6D633-97B1-4AD1-8F13-B549A5F4F458}"/>
               </a:ext>
             </a:extLst>
           </p:cNvPr>
@@ -6863,7 +6835,7 @@
                 <a:ea typeface="Consolas"/>
                 <a:cs typeface="Consolas"/>
               </a:rPr>
-              <a:t>n = len(x)</a:t>
+              <a:t>X = np.fft.rfft(x*window)</a:t>
             </a:r>
           </a:p>
           <a:p xmlns:a="http://schemas.openxmlformats.org/drawingml/2006/main">
@@ -6886,7 +6858,7 @@
                 <a:ea typeface="Consolas"/>
                 <a:cs typeface="Consolas"/>
               </a:rPr>
-              <a:t>window = np.hanning(n)</a:t>
+              <a:t>magnitude = np.abs(X)/(n*coherent_gain)</a:t>
             </a:r>
           </a:p>
           <a:p xmlns:a="http://schemas.openxmlformats.org/drawingml/2006/main">
@@ -6909,12 +6881,7 @@
                 <a:ea typeface="Consolas"/>
                 <a:cs typeface="Consolas"/>
               </a:rPr>
-              <a:t>coherent_gain = np.mean(window)</a:t>
-            </a:r>
-          </a:p>
-          <a:p xmlns:a="http://schemas.openxmlformats.org/drawingml/2006/main">
-            <a:r>
-              <a:t/>
+              <a:t>magnitude[1:-1] *= 2</a:t>
             </a:r>
           </a:p>
           <a:p xmlns:a="http://schemas.openxmlformats.org/drawingml/2006/main">
@@ -6937,7 +6904,12 @@
                 <a:ea typeface="Consolas"/>
                 <a:cs typeface="Consolas"/>
               </a:rPr>
-              <a:t>X = np.fft.rfft(x*window)</a:t>
+              <a:t>frequency = np.fft.rfftfreq(n, d=1/fs)</a:t>
+            </a:r>
+          </a:p>
+          <a:p xmlns:a="http://schemas.openxmlformats.org/drawingml/2006/main">
+            <a:r>
+              <a:t/>
             </a:r>
           </a:p>
           <a:p xmlns:a="http://schemas.openxmlformats.org/drawingml/2006/main">
@@ -6960,7 +6932,7 @@
                 <a:ea typeface="Consolas"/>
                 <a:cs typeface="Consolas"/>
               </a:rPr>
-              <a:t>magnitude = np.abs(X)/(n*coherent_gain)</a:t>
+              <a:t># Read the dominant frequencies from the output.</a:t>
             </a:r>
           </a:p>
           <a:p xmlns:a="http://schemas.openxmlformats.org/drawingml/2006/main">
@@ -6983,30 +6955,7 @@
                 <a:ea typeface="Consolas"/>
                 <a:cs typeface="Consolas"/>
               </a:rPr>
-              <a:t>magnitude[1:-1] *= 2</a:t>
-            </a:r>
-          </a:p>
-          <a:p xmlns:a="http://schemas.openxmlformats.org/drawingml/2006/main">
-            <a:pPr>
-              <a:defRPr sz="1725" b="0">
-                <a:solidFill>
-                  <a:srgbClr val="202124"/>
-                </a:solidFill>
-                <a:latin typeface="Consolas"/>
-                <a:ea typeface="Consolas"/>
-                <a:cs typeface="Consolas"/>
-              </a:defRPr>
-            </a:pPr>
-            <a:r>
-              <a:rPr sz="1725" b="0">
-                <a:solidFill>
-                  <a:srgbClr val="202124"/>
-                </a:solidFill>
-                <a:latin typeface="Consolas"/>
-                <a:ea typeface="Consolas"/>
-                <a:cs typeface="Consolas"/>
-              </a:rPr>
-              <a:t>frequency = np.fft.rfftfreq(n, d=1/fs)</a:t>
+              <a:t># Compare them with predictions made before execution.</a:t>
             </a:r>
           </a:p>
         </p:txBody>
@@ -7016,7 +6965,7 @@
           <p:cNvPr id="5" name="text">
             <a:extLst xmlns:a="http://schemas.openxmlformats.org/drawingml/2006/main">
               <a:ext uri="{FF2B5EF4-FFF2-40B4-BE49-F238E27FC236}">
-                <a16:creationId xmlns:a16="http://schemas.microsoft.com/office/drawing/2014/main" id="{20ED0A63-F708-435E-956F-3BA148C3D00B}"/>
+                <a16:creationId xmlns:a16="http://schemas.microsoft.com/office/drawing/2014/main" id="{CA5B35C3-F64A-46DB-A041-1E3D422E649E}"/>
               </a:ext>
             </a:extLst>
           </p:cNvPr>
@@ -7063,7 +7012,7 @@
                 <a:ea typeface="Calibri"/>
                 <a:cs typeface="Calibri"/>
               </a:rPr>
-              <a:t>The notebook applies a Hann window and corrects its amplitude loss.</a:t>
+              <a:t>Students interpret the FFT output. They do not write or complete these lines.</a:t>
             </a:r>
           </a:p>
         </p:txBody>
@@ -7071,7 +7020,7 @@
     </p:spTree>
     <p:extLst>
       <p:ext uri="{BB962C8B-B14F-4D97-AF65-F5344CB8AC3E}">
-        <p14:creationId xmlns:p14="http://schemas.microsoft.com/office/powerpoint/2010/main" val="585644582"/>
+        <p14:creationId xmlns:p14="http://schemas.microsoft.com/office/powerpoint/2010/main" val="1378241636"/>
       </p:ext>
     </p:extLst>
   </p:cSld>
@@ -7102,7 +7051,7 @@
           <p:cNvPr id="10" name="course">
             <a:extLst xmlns:a="http://schemas.openxmlformats.org/drawingml/2006/main">
               <a:ext uri="{FF2B5EF4-FFF2-40B4-BE49-F238E27FC236}">
-                <a16:creationId xmlns:a16="http://schemas.microsoft.com/office/drawing/2014/main" id="{873AE4CA-B055-42C4-91E2-CC72257E05E8}"/>
+                <a16:creationId xmlns:a16="http://schemas.microsoft.com/office/drawing/2014/main" id="{7227EE61-FB31-49BE-938E-1B2154DFDDDA}"/>
               </a:ext>
             </a:extLst>
           </p:cNvPr>
@@ -7159,7 +7108,7 @@
           <p:cNvPr id="2" name="title">
             <a:extLst xmlns:a="http://schemas.openxmlformats.org/drawingml/2006/main">
               <a:ext uri="{FF2B5EF4-FFF2-40B4-BE49-F238E27FC236}">
-                <a16:creationId xmlns:a16="http://schemas.microsoft.com/office/drawing/2014/main" id="{69B6250D-2F14-430B-9467-082702F94B9B}"/>
+                <a16:creationId xmlns:a16="http://schemas.microsoft.com/office/drawing/2014/main" id="{0768EED4-C4EE-48C9-B651-718A45EB84F0}"/>
               </a:ext>
             </a:extLst>
           </p:cNvPr>
@@ -7216,7 +7165,7 @@
           <p:cNvPr id="3" name="page">
             <a:extLst xmlns:a="http://schemas.openxmlformats.org/drawingml/2006/main">
               <a:ext uri="{FF2B5EF4-FFF2-40B4-BE49-F238E27FC236}">
-                <a16:creationId xmlns:a16="http://schemas.microsoft.com/office/drawing/2014/main" id="{49D5A5B3-7CB5-4F44-895C-30027C6FB980}"/>
+                <a16:creationId xmlns:a16="http://schemas.microsoft.com/office/drawing/2014/main" id="{B5DB12ED-3BCE-439F-9C6F-5AD08BDC4D4F}"/>
               </a:ext>
             </a:extLst>
           </p:cNvPr>
@@ -7273,7 +7222,7 @@
           <p:cNvPr id="4" name="text">
             <a:extLst xmlns:a="http://schemas.openxmlformats.org/drawingml/2006/main">
               <a:ext uri="{FF2B5EF4-FFF2-40B4-BE49-F238E27FC236}">
-                <a16:creationId xmlns:a16="http://schemas.microsoft.com/office/drawing/2014/main" id="{61AFCC8B-963B-4ADB-A38F-9274D2444280}"/>
+                <a16:creationId xmlns:a16="http://schemas.microsoft.com/office/drawing/2014/main" id="{BB6617B9-B34F-4BAE-A50A-0AFB9822B209}"/>
               </a:ext>
             </a:extLst>
           </p:cNvPr>
@@ -7330,7 +7279,7 @@
           <p:cNvPr id="5" name="text">
             <a:extLst xmlns:a="http://schemas.openxmlformats.org/drawingml/2006/main">
               <a:ext uri="{FF2B5EF4-FFF2-40B4-BE49-F238E27FC236}">
-                <a16:creationId xmlns:a16="http://schemas.microsoft.com/office/drawing/2014/main" id="{A5321BA4-F400-45E2-A4C5-5F0AA1C3E327}"/>
+                <a16:creationId xmlns:a16="http://schemas.microsoft.com/office/drawing/2014/main" id="{24435039-3F85-45F9-8C3B-EE1D0C5DF831}"/>
               </a:ext>
             </a:extLst>
           </p:cNvPr>
@@ -7387,7 +7336,7 @@
           <p:cNvPr id="6" name="text">
             <a:extLst xmlns:a="http://schemas.openxmlformats.org/drawingml/2006/main">
               <a:ext uri="{FF2B5EF4-FFF2-40B4-BE49-F238E27FC236}">
-                <a16:creationId xmlns:a16="http://schemas.microsoft.com/office/drawing/2014/main" id="{94EF7C13-F04E-470F-A69A-CFCE75B7A375}"/>
+                <a16:creationId xmlns:a16="http://schemas.microsoft.com/office/drawing/2014/main" id="{9E8B7720-ECB2-4FA3-9783-A8D26731890C}"/>
               </a:ext>
             </a:extLst>
           </p:cNvPr>
@@ -7444,7 +7393,7 @@
           <p:cNvPr id="7" name="text">
             <a:extLst xmlns:a="http://schemas.openxmlformats.org/drawingml/2006/main">
               <a:ext uri="{FF2B5EF4-FFF2-40B4-BE49-F238E27FC236}">
-                <a16:creationId xmlns:a16="http://schemas.microsoft.com/office/drawing/2014/main" id="{E59F1DCD-AD49-4604-A7E8-1E4F5CF0A069}"/>
+                <a16:creationId xmlns:a16="http://schemas.microsoft.com/office/drawing/2014/main" id="{ACCD9F31-C36C-4682-B7D9-EF543AB3D535}"/>
               </a:ext>
             </a:extLst>
           </p:cNvPr>
@@ -7501,7 +7450,7 @@
           <p:cNvPr id="8" name="text">
             <a:extLst xmlns:a="http://schemas.openxmlformats.org/drawingml/2006/main">
               <a:ext uri="{FF2B5EF4-FFF2-40B4-BE49-F238E27FC236}">
-                <a16:creationId xmlns:a16="http://schemas.microsoft.com/office/drawing/2014/main" id="{D8D0DDC9-EF75-4C3B-AEF5-A86EA406E9BD}"/>
+                <a16:creationId xmlns:a16="http://schemas.microsoft.com/office/drawing/2014/main" id="{EAE09A38-4305-4D62-B6A3-4DF3CA30B023}"/>
               </a:ext>
             </a:extLst>
           </p:cNvPr>
@@ -7558,7 +7507,7 @@
           <p:cNvPr id="9" name="text">
             <a:extLst xmlns:a="http://schemas.openxmlformats.org/drawingml/2006/main">
               <a:ext uri="{FF2B5EF4-FFF2-40B4-BE49-F238E27FC236}">
-                <a16:creationId xmlns:a16="http://schemas.microsoft.com/office/drawing/2014/main" id="{2E42048B-D160-4814-B42E-A90B9ACA6975}"/>
+                <a16:creationId xmlns:a16="http://schemas.microsoft.com/office/drawing/2014/main" id="{3B164C96-C91A-41C7-91B1-83B3F2623E57}"/>
               </a:ext>
             </a:extLst>
           </p:cNvPr>
@@ -7613,7 +7562,7 @@
     </p:spTree>
     <p:extLst>
       <p:ext uri="{BB962C8B-B14F-4D97-AF65-F5344CB8AC3E}">
-        <p14:creationId xmlns:p14="http://schemas.microsoft.com/office/powerpoint/2010/main" val="2041971371"/>
+        <p14:creationId xmlns:p14="http://schemas.microsoft.com/office/powerpoint/2010/main" val="22262647"/>
       </p:ext>
     </p:extLst>
   </p:cSld>
@@ -7644,7 +7593,7 @@
           <p:cNvPr id="9" name="course">
             <a:extLst xmlns:a="http://schemas.openxmlformats.org/drawingml/2006/main">
               <a:ext uri="{FF2B5EF4-FFF2-40B4-BE49-F238E27FC236}">
-                <a16:creationId xmlns:a16="http://schemas.microsoft.com/office/drawing/2014/main" id="{75CADDFF-2724-43F1-A5BC-2EE1576F3DF2}"/>
+                <a16:creationId xmlns:a16="http://schemas.microsoft.com/office/drawing/2014/main" id="{382407BE-F854-409B-8C9D-F5058DAD7A7A}"/>
               </a:ext>
             </a:extLst>
           </p:cNvPr>
@@ -7701,7 +7650,7 @@
           <p:cNvPr id="2" name="title">
             <a:extLst xmlns:a="http://schemas.openxmlformats.org/drawingml/2006/main">
               <a:ext uri="{FF2B5EF4-FFF2-40B4-BE49-F238E27FC236}">
-                <a16:creationId xmlns:a16="http://schemas.microsoft.com/office/drawing/2014/main" id="{E45171CF-AEBD-4DFF-A7F1-F36481314BCC}"/>
+                <a16:creationId xmlns:a16="http://schemas.microsoft.com/office/drawing/2014/main" id="{195A9A26-5E50-4BA5-8D72-442D35A0A71C}"/>
               </a:ext>
             </a:extLst>
           </p:cNvPr>
@@ -7758,7 +7707,7 @@
           <p:cNvPr id="3" name="page">
             <a:extLst xmlns:a="http://schemas.openxmlformats.org/drawingml/2006/main">
               <a:ext uri="{FF2B5EF4-FFF2-40B4-BE49-F238E27FC236}">
-                <a16:creationId xmlns:a16="http://schemas.microsoft.com/office/drawing/2014/main" id="{F516F658-8671-414B-8B95-44013372A947}"/>
+                <a16:creationId xmlns:a16="http://schemas.microsoft.com/office/drawing/2014/main" id="{CDE41A73-B86C-42BA-B72B-5DC7746056F9}"/>
               </a:ext>
             </a:extLst>
           </p:cNvPr>
@@ -7815,7 +7764,7 @@
           <p:cNvPr id="4" name="text">
             <a:extLst xmlns:a="http://schemas.openxmlformats.org/drawingml/2006/main">
               <a:ext uri="{FF2B5EF4-FFF2-40B4-BE49-F238E27FC236}">
-                <a16:creationId xmlns:a16="http://schemas.microsoft.com/office/drawing/2014/main" id="{3E3709B1-5745-4AE3-AD59-E654426406A1}"/>
+                <a16:creationId xmlns:a16="http://schemas.microsoft.com/office/drawing/2014/main" id="{50376216-3F34-45B0-B5AA-1D15DBC8C6E4}"/>
               </a:ext>
             </a:extLst>
           </p:cNvPr>
@@ -7872,7 +7821,7 @@
           <p:cNvPr id="5" name="text">
             <a:extLst xmlns:a="http://schemas.openxmlformats.org/drawingml/2006/main">
               <a:ext uri="{FF2B5EF4-FFF2-40B4-BE49-F238E27FC236}">
-                <a16:creationId xmlns:a16="http://schemas.microsoft.com/office/drawing/2014/main" id="{5336225C-B64D-4302-B280-77DEFCB93C8F}"/>
+                <a16:creationId xmlns:a16="http://schemas.microsoft.com/office/drawing/2014/main" id="{CAF6D8AC-76F7-4E51-AA33-52B67CBFD640}"/>
               </a:ext>
             </a:extLst>
           </p:cNvPr>
@@ -7929,7 +7878,7 @@
           <p:cNvPr id="6" name="text">
             <a:extLst xmlns:a="http://schemas.openxmlformats.org/drawingml/2006/main">
               <a:ext uri="{FF2B5EF4-FFF2-40B4-BE49-F238E27FC236}">
-                <a16:creationId xmlns:a16="http://schemas.microsoft.com/office/drawing/2014/main" id="{7EED137D-3CE7-4633-BCD7-AAB843659519}"/>
+                <a16:creationId xmlns:a16="http://schemas.microsoft.com/office/drawing/2014/main" id="{4C4614D1-47B2-48D9-AC45-7E2E30F549AC}"/>
               </a:ext>
             </a:extLst>
           </p:cNvPr>
@@ -7986,7 +7935,7 @@
           <p:cNvPr id="7" name="text">
             <a:extLst xmlns:a="http://schemas.openxmlformats.org/drawingml/2006/main">
               <a:ext uri="{FF2B5EF4-FFF2-40B4-BE49-F238E27FC236}">
-                <a16:creationId xmlns:a16="http://schemas.microsoft.com/office/drawing/2014/main" id="{A2B78106-7A64-4898-AA7B-E9CA9CCD1568}"/>
+                <a16:creationId xmlns:a16="http://schemas.microsoft.com/office/drawing/2014/main" id="{69C6D9B3-FC7B-409D-9FBC-EB9795DB9CD9}"/>
               </a:ext>
             </a:extLst>
           </p:cNvPr>
@@ -8043,7 +7992,7 @@
           <p:cNvPr id="8" name="text">
             <a:extLst xmlns:a="http://schemas.openxmlformats.org/drawingml/2006/main">
               <a:ext uri="{FF2B5EF4-FFF2-40B4-BE49-F238E27FC236}">
-                <a16:creationId xmlns:a16="http://schemas.microsoft.com/office/drawing/2014/main" id="{8EF79C6D-723A-4C99-BC02-BBFCF74B09E0}"/>
+                <a16:creationId xmlns:a16="http://schemas.microsoft.com/office/drawing/2014/main" id="{75E39673-2D32-45A0-B15F-703CAE027E7F}"/>
               </a:ext>
             </a:extLst>
           </p:cNvPr>
@@ -8098,7 +8047,7 @@
     </p:spTree>
     <p:extLst>
       <p:ext uri="{BB962C8B-B14F-4D97-AF65-F5344CB8AC3E}">
-        <p14:creationId xmlns:p14="http://schemas.microsoft.com/office/powerpoint/2010/main" val="2136929863"/>
+        <p14:creationId xmlns:p14="http://schemas.microsoft.com/office/powerpoint/2010/main" val="1502373141"/>
       </p:ext>
     </p:extLst>
   </p:cSld>
@@ -8129,7 +8078,7 @@
           <p:cNvPr id="12" name="course">
             <a:extLst xmlns:a="http://schemas.openxmlformats.org/drawingml/2006/main">
               <a:ext uri="{FF2B5EF4-FFF2-40B4-BE49-F238E27FC236}">
-                <a16:creationId xmlns:a16="http://schemas.microsoft.com/office/drawing/2014/main" id="{860CC3D7-8AA0-451B-AA26-078B9D616C94}"/>
+                <a16:creationId xmlns:a16="http://schemas.microsoft.com/office/drawing/2014/main" id="{2C515B10-E412-4CEB-9962-57FA27CC6A30}"/>
               </a:ext>
             </a:extLst>
           </p:cNvPr>
@@ -8186,7 +8135,7 @@
           <p:cNvPr id="2" name="title">
             <a:extLst xmlns:a="http://schemas.openxmlformats.org/drawingml/2006/main">
               <a:ext uri="{FF2B5EF4-FFF2-40B4-BE49-F238E27FC236}">
-                <a16:creationId xmlns:a16="http://schemas.microsoft.com/office/drawing/2014/main" id="{5A77AFFD-4042-41F6-8260-EACF4941208B}"/>
+                <a16:creationId xmlns:a16="http://schemas.microsoft.com/office/drawing/2014/main" id="{E14F5FED-F56D-4264-9AE3-6B8D115A2895}"/>
               </a:ext>
             </a:extLst>
           </p:cNvPr>
@@ -8233,7 +8182,7 @@
                 <a:ea typeface="Calibri"/>
                 <a:cs typeface="Calibri"/>
               </a:rPr>
-              <a:t>Required student responses</a:t>
+              <a:t>Required data analysis</a:t>
             </a:r>
           </a:p>
         </p:txBody>
@@ -8243,7 +8192,7 @@
           <p:cNvPr id="3" name="page">
             <a:extLst xmlns:a="http://schemas.openxmlformats.org/drawingml/2006/main">
               <a:ext uri="{FF2B5EF4-FFF2-40B4-BE49-F238E27FC236}">
-                <a16:creationId xmlns:a16="http://schemas.microsoft.com/office/drawing/2014/main" id="{B1C6FECF-5F8B-4577-AB25-1F464E1DA301}"/>
+                <a16:creationId xmlns:a16="http://schemas.microsoft.com/office/drawing/2014/main" id="{C584FC53-BFBA-4BFC-9523-A643D7CD8500}"/>
               </a:ext>
             </a:extLst>
           </p:cNvPr>
@@ -8300,7 +8249,7 @@
           <p:cNvPr id="4" name="text">
             <a:extLst xmlns:a="http://schemas.openxmlformats.org/drawingml/2006/main">
               <a:ext uri="{FF2B5EF4-FFF2-40B4-BE49-F238E27FC236}">
-                <a16:creationId xmlns:a16="http://schemas.microsoft.com/office/drawing/2014/main" id="{330981C6-6787-4868-90D2-87B9A1050C94}"/>
+                <a16:creationId xmlns:a16="http://schemas.microsoft.com/office/drawing/2014/main" id="{00ABF2DD-25D4-4062-BD7E-45B8446B4C7F}"/>
               </a:ext>
             </a:extLst>
           </p:cNvPr>
@@ -8357,7 +8306,7 @@
           <p:cNvPr id="5" name="text">
             <a:extLst xmlns:a="http://schemas.openxmlformats.org/drawingml/2006/main">
               <a:ext uri="{FF2B5EF4-FFF2-40B4-BE49-F238E27FC236}">
-                <a16:creationId xmlns:a16="http://schemas.microsoft.com/office/drawing/2014/main" id="{57FB69C4-D3E9-4CD1-AB0D-147577D6CF14}"/>
+                <a16:creationId xmlns:a16="http://schemas.microsoft.com/office/drawing/2014/main" id="{62D174AD-9F16-4D26-BE7A-EEEFA74B7BA0}"/>
               </a:ext>
             </a:extLst>
           </p:cNvPr>
@@ -8404,7 +8353,7 @@
                 <a:ea typeface="Calibri"/>
                 <a:cs typeface="Calibri"/>
               </a:rPr>
-              <a:t>Show the theoretical mean and RMS calculation</a:t>
+              <a:t>Calculate theoretical mean and RMS, then compute RMS percent errors</a:t>
             </a:r>
           </a:p>
         </p:txBody>
@@ -8414,7 +8363,7 @@
           <p:cNvPr id="6" name="text">
             <a:extLst xmlns:a="http://schemas.openxmlformats.org/drawingml/2006/main">
               <a:ext uri="{FF2B5EF4-FFF2-40B4-BE49-F238E27FC236}">
-                <a16:creationId xmlns:a16="http://schemas.microsoft.com/office/drawing/2014/main" id="{D135B928-F00D-4605-8B34-1AF2968E32A1}"/>
+                <a16:creationId xmlns:a16="http://schemas.microsoft.com/office/drawing/2014/main" id="{2CF65E71-9EA5-4537-BDDA-4041607E2731}"/>
               </a:ext>
             </a:extLst>
           </p:cNvPr>
@@ -8471,7 +8420,7 @@
           <p:cNvPr id="7" name="text">
             <a:extLst xmlns:a="http://schemas.openxmlformats.org/drawingml/2006/main">
               <a:ext uri="{FF2B5EF4-FFF2-40B4-BE49-F238E27FC236}">
-                <a16:creationId xmlns:a16="http://schemas.microsoft.com/office/drawing/2014/main" id="{359D0079-639A-4B5D-B806-24DCB1017E8D}"/>
+                <a16:creationId xmlns:a16="http://schemas.microsoft.com/office/drawing/2014/main" id="{EE561BDD-042F-4B13-B0E7-15C094091DFC}"/>
               </a:ext>
             </a:extLst>
           </p:cNvPr>
@@ -8518,7 +8467,7 @@
                 <a:ea typeface="Calibri"/>
                 <a:cs typeface="Calibri"/>
               </a:rPr>
-              <a:t>Compare sampled mean and RMS values with theory</a:t>
+              <a:t>Predict every FFT peak before viewing the spectra</a:t>
             </a:r>
           </a:p>
         </p:txBody>
@@ -8528,7 +8477,7 @@
           <p:cNvPr id="8" name="text">
             <a:extLst xmlns:a="http://schemas.openxmlformats.org/drawingml/2006/main">
               <a:ext uri="{FF2B5EF4-FFF2-40B4-BE49-F238E27FC236}">
-                <a16:creationId xmlns:a16="http://schemas.microsoft.com/office/drawing/2014/main" id="{1F0982CF-53F1-4177-9835-C7151DC8FF14}"/>
+                <a16:creationId xmlns:a16="http://schemas.microsoft.com/office/drawing/2014/main" id="{0F2F3E36-CDF7-4443-B7E4-3B4AE69AEFEF}"/>
               </a:ext>
             </a:extLst>
           </p:cNvPr>
@@ -8585,7 +8534,7 @@
           <p:cNvPr id="9" name="text">
             <a:extLst xmlns:a="http://schemas.openxmlformats.org/drawingml/2006/main">
               <a:ext uri="{FF2B5EF4-FFF2-40B4-BE49-F238E27FC236}">
-                <a16:creationId xmlns:a16="http://schemas.microsoft.com/office/drawing/2014/main" id="{89211967-913D-4CD1-B636-E7D6175D2791}"/>
+                <a16:creationId xmlns:a16="http://schemas.microsoft.com/office/drawing/2014/main" id="{91FFC997-C763-4952-8BD6-9D09ECBA4829}"/>
               </a:ext>
             </a:extLst>
           </p:cNvPr>
@@ -8632,7 +8581,7 @@
                 <a:ea typeface="Calibri"/>
                 <a:cs typeface="Calibri"/>
               </a:rPr>
-              <a:t>List the two dominant frequencies for every sample rate</a:t>
+              <a:t>Compare predicted and observed peaks and explain aliasing</a:t>
             </a:r>
           </a:p>
         </p:txBody>
@@ -8642,7 +8591,7 @@
           <p:cNvPr id="10" name="text">
             <a:extLst xmlns:a="http://schemas.openxmlformats.org/drawingml/2006/main">
               <a:ext uri="{FF2B5EF4-FFF2-40B4-BE49-F238E27FC236}">
-                <a16:creationId xmlns:a16="http://schemas.microsoft.com/office/drawing/2014/main" id="{55F98D50-E711-4E78-A15B-DC93ED843285}"/>
+                <a16:creationId xmlns:a16="http://schemas.microsoft.com/office/drawing/2014/main" id="{24F5E090-F5B8-46F9-81B6-B1040DE74A0F}"/>
               </a:ext>
             </a:extLst>
           </p:cNvPr>
@@ -8699,7 +8648,7 @@
           <p:cNvPr id="11" name="text">
             <a:extLst xmlns:a="http://schemas.openxmlformats.org/drawingml/2006/main">
               <a:ext uri="{FF2B5EF4-FFF2-40B4-BE49-F238E27FC236}">
-                <a16:creationId xmlns:a16="http://schemas.microsoft.com/office/drawing/2014/main" id="{91FD5CE4-B849-4555-A0B7-87CA849F456B}"/>
+                <a16:creationId xmlns:a16="http://schemas.microsoft.com/office/drawing/2014/main" id="{6B34BDA8-E691-41A4-A512-130F56E69D2C}"/>
               </a:ext>
             </a:extLst>
           </p:cNvPr>
@@ -8746,7 +8695,7 @@
                 <a:ea typeface="Calibri"/>
                 <a:cs typeface="Calibri"/>
               </a:rPr>
-              <a:t>Explain the aliased frequencies and connect the result to Lab 1</a:t>
+              <a:t>Choose a sample rate and duration for a new measurement and justify both</a:t>
             </a:r>
           </a:p>
         </p:txBody>
@@ -8754,7 +8703,7 @@
     </p:spTree>
     <p:extLst>
       <p:ext uri="{BB962C8B-B14F-4D97-AF65-F5344CB8AC3E}">
-        <p14:creationId xmlns:p14="http://schemas.microsoft.com/office/powerpoint/2010/main" val="816985452"/>
+        <p14:creationId xmlns:p14="http://schemas.microsoft.com/office/powerpoint/2010/main" val="226394027"/>
       </p:ext>
     </p:extLst>
   </p:cSld>
@@ -8785,7 +8734,7 @@
           <p:cNvPr id="12" name="course">
             <a:extLst xmlns:a="http://schemas.openxmlformats.org/drawingml/2006/main">
               <a:ext uri="{FF2B5EF4-FFF2-40B4-BE49-F238E27FC236}">
-                <a16:creationId xmlns:a16="http://schemas.microsoft.com/office/drawing/2014/main" id="{0AE815AA-2297-4F4D-AAD7-CFC360645D98}"/>
+                <a16:creationId xmlns:a16="http://schemas.microsoft.com/office/drawing/2014/main" id="{1B5E944B-5900-4B17-9FDC-73FFAAAB7F1E}"/>
               </a:ext>
             </a:extLst>
           </p:cNvPr>
@@ -8842,7 +8791,7 @@
           <p:cNvPr id="2" name="title">
             <a:extLst xmlns:a="http://schemas.openxmlformats.org/drawingml/2006/main">
               <a:ext uri="{FF2B5EF4-FFF2-40B4-BE49-F238E27FC236}">
-                <a16:creationId xmlns:a16="http://schemas.microsoft.com/office/drawing/2014/main" id="{1FD640B6-D0EB-4B9B-9BCE-4DB1DC355F63}"/>
+                <a16:creationId xmlns:a16="http://schemas.microsoft.com/office/drawing/2014/main" id="{E9C35B37-8D01-46D1-9B9F-F0FA9F1AAFD6}"/>
               </a:ext>
             </a:extLst>
           </p:cNvPr>
@@ -8899,7 +8848,7 @@
           <p:cNvPr id="3" name="page">
             <a:extLst xmlns:a="http://schemas.openxmlformats.org/drawingml/2006/main">
               <a:ext uri="{FF2B5EF4-FFF2-40B4-BE49-F238E27FC236}">
-                <a16:creationId xmlns:a16="http://schemas.microsoft.com/office/drawing/2014/main" id="{6A81784A-69E7-4255-8641-3ED6BDE778E5}"/>
+                <a16:creationId xmlns:a16="http://schemas.microsoft.com/office/drawing/2014/main" id="{09D095AF-1CA0-4EFB-90B6-3D21A8CEF6BE}"/>
               </a:ext>
             </a:extLst>
           </p:cNvPr>
@@ -8956,7 +8905,7 @@
           <p:cNvPr id="4" name="text">
             <a:extLst xmlns:a="http://schemas.openxmlformats.org/drawingml/2006/main">
               <a:ext uri="{FF2B5EF4-FFF2-40B4-BE49-F238E27FC236}">
-                <a16:creationId xmlns:a16="http://schemas.microsoft.com/office/drawing/2014/main" id="{E6C6FF18-4575-40D8-9E37-6CA29E844EC3}"/>
+                <a16:creationId xmlns:a16="http://schemas.microsoft.com/office/drawing/2014/main" id="{79ADC1DE-B830-4CF1-944C-814B3F1A10F0}"/>
               </a:ext>
             </a:extLst>
           </p:cNvPr>
@@ -9013,7 +8962,7 @@
           <p:cNvPr id="5" name="text">
             <a:extLst xmlns:a="http://schemas.openxmlformats.org/drawingml/2006/main">
               <a:ext uri="{FF2B5EF4-FFF2-40B4-BE49-F238E27FC236}">
-                <a16:creationId xmlns:a16="http://schemas.microsoft.com/office/drawing/2014/main" id="{56D2ABD8-82BE-4466-86FA-CF89DDB619FE}"/>
+                <a16:creationId xmlns:a16="http://schemas.microsoft.com/office/drawing/2014/main" id="{472C652E-CC69-4341-BE3A-F7B2335B7DD7}"/>
               </a:ext>
             </a:extLst>
           </p:cNvPr>
@@ -9070,7 +9019,7 @@
           <p:cNvPr id="6" name="text">
             <a:extLst xmlns:a="http://schemas.openxmlformats.org/drawingml/2006/main">
               <a:ext uri="{FF2B5EF4-FFF2-40B4-BE49-F238E27FC236}">
-                <a16:creationId xmlns:a16="http://schemas.microsoft.com/office/drawing/2014/main" id="{7F0310DA-C5CD-435F-853E-F5039EC8A2A2}"/>
+                <a16:creationId xmlns:a16="http://schemas.microsoft.com/office/drawing/2014/main" id="{F20F3F84-52D7-4EA5-8FF9-3AEDCB5F2B64}"/>
               </a:ext>
             </a:extLst>
           </p:cNvPr>
@@ -9127,7 +9076,7 @@
           <p:cNvPr id="7" name="text">
             <a:extLst xmlns:a="http://schemas.openxmlformats.org/drawingml/2006/main">
               <a:ext uri="{FF2B5EF4-FFF2-40B4-BE49-F238E27FC236}">
-                <a16:creationId xmlns:a16="http://schemas.microsoft.com/office/drawing/2014/main" id="{0C53DEDA-B02E-48BA-8AB4-BCC835877047}"/>
+                <a16:creationId xmlns:a16="http://schemas.microsoft.com/office/drawing/2014/main" id="{5FC631A5-1F8C-4A02-BCDC-8EAEAFD72CD5}"/>
               </a:ext>
             </a:extLst>
           </p:cNvPr>
@@ -9174,7 +9123,7 @@
                 <a:ea typeface="Calibri"/>
                 <a:cs typeface="Calibri"/>
               </a:rPr>
-              <a:t>Run code and Markdown cells in a Jupyter notebook</a:t>
+              <a:t>Run prepared analysis cells in a Jupyter notebook</a:t>
             </a:r>
           </a:p>
         </p:txBody>
@@ -9184,7 +9133,7 @@
           <p:cNvPr id="8" name="text">
             <a:extLst xmlns:a="http://schemas.openxmlformats.org/drawingml/2006/main">
               <a:ext uri="{FF2B5EF4-FFF2-40B4-BE49-F238E27FC236}">
-                <a16:creationId xmlns:a16="http://schemas.microsoft.com/office/drawing/2014/main" id="{AB746F2C-2B4B-41EB-9366-574646F94185}"/>
+                <a16:creationId xmlns:a16="http://schemas.microsoft.com/office/drawing/2014/main" id="{196A452A-8204-4823-A117-717DA3BEB6E1}"/>
               </a:ext>
             </a:extLst>
           </p:cNvPr>
@@ -9241,7 +9190,7 @@
           <p:cNvPr id="9" name="text">
             <a:extLst xmlns:a="http://schemas.openxmlformats.org/drawingml/2006/main">
               <a:ext uri="{FF2B5EF4-FFF2-40B4-BE49-F238E27FC236}">
-                <a16:creationId xmlns:a16="http://schemas.microsoft.com/office/drawing/2014/main" id="{D070FBCF-9BFE-45DB-8BE7-36BA744EDB7C}"/>
+                <a16:creationId xmlns:a16="http://schemas.microsoft.com/office/drawing/2014/main" id="{92ACA28E-18E5-48B9-9786-6A34C46A2B57}"/>
               </a:ext>
             </a:extLst>
           </p:cNvPr>
@@ -9298,7 +9247,7 @@
           <p:cNvPr id="10" name="text">
             <a:extLst xmlns:a="http://schemas.openxmlformats.org/drawingml/2006/main">
               <a:ext uri="{FF2B5EF4-FFF2-40B4-BE49-F238E27FC236}">
-                <a16:creationId xmlns:a16="http://schemas.microsoft.com/office/drawing/2014/main" id="{B071073C-C44F-479A-B0DD-B9FB8D06250A}"/>
+                <a16:creationId xmlns:a16="http://schemas.microsoft.com/office/drawing/2014/main" id="{6A5B676F-631D-4D3F-8CA4-E31B7686ECED}"/>
               </a:ext>
             </a:extLst>
           </p:cNvPr>
@@ -9355,7 +9304,7 @@
           <p:cNvPr id="11" name="text">
             <a:extLst xmlns:a="http://schemas.openxmlformats.org/drawingml/2006/main">
               <a:ext uri="{FF2B5EF4-FFF2-40B4-BE49-F238E27FC236}">
-                <a16:creationId xmlns:a16="http://schemas.microsoft.com/office/drawing/2014/main" id="{EFC4778E-BAA3-4567-94A5-C42996FDCC53}"/>
+                <a16:creationId xmlns:a16="http://schemas.microsoft.com/office/drawing/2014/main" id="{4A5E2657-98A0-4373-B3EE-F7F1833B2A1F}"/>
               </a:ext>
             </a:extLst>
           </p:cNvPr>
@@ -9410,7 +9359,7 @@
     </p:spTree>
     <p:extLst>
       <p:ext uri="{BB962C8B-B14F-4D97-AF65-F5344CB8AC3E}">
-        <p14:creationId xmlns:p14="http://schemas.microsoft.com/office/powerpoint/2010/main" val="1351093549"/>
+        <p14:creationId xmlns:p14="http://schemas.microsoft.com/office/powerpoint/2010/main" val="1585465589"/>
       </p:ext>
     </p:extLst>
   </p:cSld>
@@ -9441,7 +9390,7 @@
           <p:cNvPr id="13" name="course">
             <a:extLst xmlns:a="http://schemas.openxmlformats.org/drawingml/2006/main">
               <a:ext uri="{FF2B5EF4-FFF2-40B4-BE49-F238E27FC236}">
-                <a16:creationId xmlns:a16="http://schemas.microsoft.com/office/drawing/2014/main" id="{B5C7B9C8-1556-4E81-91EF-FAC866E36717}"/>
+                <a16:creationId xmlns:a16="http://schemas.microsoft.com/office/drawing/2014/main" id="{DCCEEE79-CBD2-437E-8AB1-C62B164E091D}"/>
               </a:ext>
             </a:extLst>
           </p:cNvPr>
@@ -9498,7 +9447,7 @@
           <p:cNvPr id="2" name="title">
             <a:extLst xmlns:a="http://schemas.openxmlformats.org/drawingml/2006/main">
               <a:ext uri="{FF2B5EF4-FFF2-40B4-BE49-F238E27FC236}">
-                <a16:creationId xmlns:a16="http://schemas.microsoft.com/office/drawing/2014/main" id="{A7EC4247-6B46-4A3A-A0C7-871D79FF816B}"/>
+                <a16:creationId xmlns:a16="http://schemas.microsoft.com/office/drawing/2014/main" id="{3B88D519-C9CE-43CE-9029-33AE5BE115FA}"/>
               </a:ext>
             </a:extLst>
           </p:cNvPr>
@@ -9555,7 +9504,7 @@
           <p:cNvPr id="3" name="page">
             <a:extLst xmlns:a="http://schemas.openxmlformats.org/drawingml/2006/main">
               <a:ext uri="{FF2B5EF4-FFF2-40B4-BE49-F238E27FC236}">
-                <a16:creationId xmlns:a16="http://schemas.microsoft.com/office/drawing/2014/main" id="{3B7E227C-38C3-471F-874C-DC696431C0C5}"/>
+                <a16:creationId xmlns:a16="http://schemas.microsoft.com/office/drawing/2014/main" id="{734DE9E0-BC58-442F-8C6F-4902B31E3083}"/>
               </a:ext>
             </a:extLst>
           </p:cNvPr>
@@ -9612,7 +9561,7 @@
           <p:cNvPr id="4" name="text">
             <a:extLst xmlns:a="http://schemas.openxmlformats.org/drawingml/2006/main">
               <a:ext uri="{FF2B5EF4-FFF2-40B4-BE49-F238E27FC236}">
-                <a16:creationId xmlns:a16="http://schemas.microsoft.com/office/drawing/2014/main" id="{00E6A981-F231-4206-82B1-00AE611EC43F}"/>
+                <a16:creationId xmlns:a16="http://schemas.microsoft.com/office/drawing/2014/main" id="{FC0A5FB1-2DC4-4339-B72E-9F471D71D8DC}"/>
               </a:ext>
             </a:extLst>
           </p:cNvPr>
@@ -9669,7 +9618,7 @@
           <p:cNvPr id="5" name="text">
             <a:extLst xmlns:a="http://schemas.openxmlformats.org/drawingml/2006/main">
               <a:ext uri="{FF2B5EF4-FFF2-40B4-BE49-F238E27FC236}">
-                <a16:creationId xmlns:a16="http://schemas.microsoft.com/office/drawing/2014/main" id="{C6233AD0-68BC-47DE-8985-088A17FA8A75}"/>
+                <a16:creationId xmlns:a16="http://schemas.microsoft.com/office/drawing/2014/main" id="{8A3FCB8B-E880-49A7-9E43-F09DC07C178D}"/>
               </a:ext>
             </a:extLst>
           </p:cNvPr>
@@ -9726,7 +9675,7 @@
           <p:cNvPr id="6" name="text">
             <a:extLst xmlns:a="http://schemas.openxmlformats.org/drawingml/2006/main">
               <a:ext uri="{FF2B5EF4-FFF2-40B4-BE49-F238E27FC236}">
-                <a16:creationId xmlns:a16="http://schemas.microsoft.com/office/drawing/2014/main" id="{7B796A43-2117-400E-B2F5-6183EB73DA24}"/>
+                <a16:creationId xmlns:a16="http://schemas.microsoft.com/office/drawing/2014/main" id="{9721B461-1CA1-4676-8695-B5B88BF97467}"/>
               </a:ext>
             </a:extLst>
           </p:cNvPr>
@@ -9783,7 +9732,7 @@
           <p:cNvPr id="7" name="text">
             <a:extLst xmlns:a="http://schemas.openxmlformats.org/drawingml/2006/main">
               <a:ext uri="{FF2B5EF4-FFF2-40B4-BE49-F238E27FC236}">
-                <a16:creationId xmlns:a16="http://schemas.microsoft.com/office/drawing/2014/main" id="{2F17D70D-D038-4DB4-80C4-902782A96016}"/>
+                <a16:creationId xmlns:a16="http://schemas.microsoft.com/office/drawing/2014/main" id="{DADCB236-1A34-42C3-8F19-CC490A5BA630}"/>
               </a:ext>
             </a:extLst>
           </p:cNvPr>
@@ -9840,7 +9789,7 @@
           <p:cNvPr id="8" name="text">
             <a:extLst xmlns:a="http://schemas.openxmlformats.org/drawingml/2006/main">
               <a:ext uri="{FF2B5EF4-FFF2-40B4-BE49-F238E27FC236}">
-                <a16:creationId xmlns:a16="http://schemas.microsoft.com/office/drawing/2014/main" id="{660E96AF-B938-4792-8A47-41D0178C792D}"/>
+                <a16:creationId xmlns:a16="http://schemas.microsoft.com/office/drawing/2014/main" id="{53EBE5A9-1A60-4990-9361-EB9F2035C068}"/>
               </a:ext>
             </a:extLst>
           </p:cNvPr>
@@ -9897,7 +9846,7 @@
           <p:cNvPr id="9" name="text">
             <a:extLst xmlns:a="http://schemas.openxmlformats.org/drawingml/2006/main">
               <a:ext uri="{FF2B5EF4-FFF2-40B4-BE49-F238E27FC236}">
-                <a16:creationId xmlns:a16="http://schemas.microsoft.com/office/drawing/2014/main" id="{56E289E7-032F-4445-91C9-4B0EFE4848E7}"/>
+                <a16:creationId xmlns:a16="http://schemas.microsoft.com/office/drawing/2014/main" id="{A57FFC79-A10B-475A-8B9C-96ABC3291241}"/>
               </a:ext>
             </a:extLst>
           </p:cNvPr>
@@ -9954,7 +9903,7 @@
           <p:cNvPr id="10" name="text">
             <a:extLst xmlns:a="http://schemas.openxmlformats.org/drawingml/2006/main">
               <a:ext uri="{FF2B5EF4-FFF2-40B4-BE49-F238E27FC236}">
-                <a16:creationId xmlns:a16="http://schemas.microsoft.com/office/drawing/2014/main" id="{A3067205-378D-4020-BE2A-578E5C3D0CF2}"/>
+                <a16:creationId xmlns:a16="http://schemas.microsoft.com/office/drawing/2014/main" id="{0DEA1642-1D33-47FD-88DB-B4F84E42EC0E}"/>
               </a:ext>
             </a:extLst>
           </p:cNvPr>
@@ -10011,7 +9960,7 @@
           <p:cNvPr id="11" name="text">
             <a:extLst xmlns:a="http://schemas.openxmlformats.org/drawingml/2006/main">
               <a:ext uri="{FF2B5EF4-FFF2-40B4-BE49-F238E27FC236}">
-                <a16:creationId xmlns:a16="http://schemas.microsoft.com/office/drawing/2014/main" id="{8B4F97BF-9342-4C2F-9072-A1E573D091E9}"/>
+                <a16:creationId xmlns:a16="http://schemas.microsoft.com/office/drawing/2014/main" id="{7635DD1E-E3B3-418C-9D21-1AB6A0874B8C}"/>
               </a:ext>
             </a:extLst>
           </p:cNvPr>
@@ -10068,7 +10017,7 @@
           <p:cNvPr id="12" name="text">
             <a:extLst xmlns:a="http://schemas.openxmlformats.org/drawingml/2006/main">
               <a:ext uri="{FF2B5EF4-FFF2-40B4-BE49-F238E27FC236}">
-                <a16:creationId xmlns:a16="http://schemas.microsoft.com/office/drawing/2014/main" id="{E9C82278-0DC4-4FB7-976E-9B46FF24FE1D}"/>
+                <a16:creationId xmlns:a16="http://schemas.microsoft.com/office/drawing/2014/main" id="{96760160-499F-4766-9993-1BFD210DC59B}"/>
               </a:ext>
             </a:extLst>
           </p:cNvPr>
@@ -10123,7 +10072,7 @@
     </p:spTree>
     <p:extLst>
       <p:ext uri="{BB962C8B-B14F-4D97-AF65-F5344CB8AC3E}">
-        <p14:creationId xmlns:p14="http://schemas.microsoft.com/office/powerpoint/2010/main" val="1661416537"/>
+        <p14:creationId xmlns:p14="http://schemas.microsoft.com/office/powerpoint/2010/main" val="1412626432"/>
       </p:ext>
     </p:extLst>
   </p:cSld>
@@ -10154,7 +10103,7 @@
           <p:cNvPr id="12" name="course">
             <a:extLst xmlns:a="http://schemas.openxmlformats.org/drawingml/2006/main">
               <a:ext uri="{FF2B5EF4-FFF2-40B4-BE49-F238E27FC236}">
-                <a16:creationId xmlns:a16="http://schemas.microsoft.com/office/drawing/2014/main" id="{41371900-FAD9-476A-A2C4-092264238CEF}"/>
+                <a16:creationId xmlns:a16="http://schemas.microsoft.com/office/drawing/2014/main" id="{2EC8AFC1-CF23-443A-959A-6231F90D6AFF}"/>
               </a:ext>
             </a:extLst>
           </p:cNvPr>
@@ -10211,7 +10160,7 @@
           <p:cNvPr id="2" name="title">
             <a:extLst xmlns:a="http://schemas.openxmlformats.org/drawingml/2006/main">
               <a:ext uri="{FF2B5EF4-FFF2-40B4-BE49-F238E27FC236}">
-                <a16:creationId xmlns:a16="http://schemas.microsoft.com/office/drawing/2014/main" id="{04700CCA-D118-4448-8A42-C137CAA25218}"/>
+                <a16:creationId xmlns:a16="http://schemas.microsoft.com/office/drawing/2014/main" id="{FABD792D-DF6D-4471-8034-88CB800F52CD}"/>
               </a:ext>
             </a:extLst>
           </p:cNvPr>
@@ -10268,7 +10217,7 @@
           <p:cNvPr id="3" name="page">
             <a:extLst xmlns:a="http://schemas.openxmlformats.org/drawingml/2006/main">
               <a:ext uri="{FF2B5EF4-FFF2-40B4-BE49-F238E27FC236}">
-                <a16:creationId xmlns:a16="http://schemas.microsoft.com/office/drawing/2014/main" id="{4E28673D-CDCA-4547-BF03-81A6953D8EC5}"/>
+                <a16:creationId xmlns:a16="http://schemas.microsoft.com/office/drawing/2014/main" id="{587916DE-1D99-4665-8FE7-FAE6DA164164}"/>
               </a:ext>
             </a:extLst>
           </p:cNvPr>
@@ -10325,7 +10274,7 @@
           <p:cNvPr id="4" name="text">
             <a:extLst xmlns:a="http://schemas.openxmlformats.org/drawingml/2006/main">
               <a:ext uri="{FF2B5EF4-FFF2-40B4-BE49-F238E27FC236}">
-                <a16:creationId xmlns:a16="http://schemas.microsoft.com/office/drawing/2014/main" id="{A0AA0BA8-AFFB-43FB-BF89-839265B3A620}"/>
+                <a16:creationId xmlns:a16="http://schemas.microsoft.com/office/drawing/2014/main" id="{0C97733B-A04B-4A77-B952-C72ACC009404}"/>
               </a:ext>
             </a:extLst>
           </p:cNvPr>
@@ -10382,7 +10331,7 @@
           <p:cNvPr id="5" name="text">
             <a:extLst xmlns:a="http://schemas.openxmlformats.org/drawingml/2006/main">
               <a:ext uri="{FF2B5EF4-FFF2-40B4-BE49-F238E27FC236}">
-                <a16:creationId xmlns:a16="http://schemas.microsoft.com/office/drawing/2014/main" id="{48851B51-2EBD-415F-8448-080A5B4310FD}"/>
+                <a16:creationId xmlns:a16="http://schemas.microsoft.com/office/drawing/2014/main" id="{517CA938-E691-4751-900C-60BDA6094F45}"/>
               </a:ext>
             </a:extLst>
           </p:cNvPr>
@@ -10439,7 +10388,7 @@
           <p:cNvPr id="6" name="text">
             <a:extLst xmlns:a="http://schemas.openxmlformats.org/drawingml/2006/main">
               <a:ext uri="{FF2B5EF4-FFF2-40B4-BE49-F238E27FC236}">
-                <a16:creationId xmlns:a16="http://schemas.microsoft.com/office/drawing/2014/main" id="{EF8290CC-E3A8-41BB-AD1D-1B7971832475}"/>
+                <a16:creationId xmlns:a16="http://schemas.microsoft.com/office/drawing/2014/main" id="{93B029C3-F085-41D4-9820-B4436AD19C39}"/>
               </a:ext>
             </a:extLst>
           </p:cNvPr>
@@ -10496,7 +10445,7 @@
           <p:cNvPr id="7" name="text">
             <a:extLst xmlns:a="http://schemas.openxmlformats.org/drawingml/2006/main">
               <a:ext uri="{FF2B5EF4-FFF2-40B4-BE49-F238E27FC236}">
-                <a16:creationId xmlns:a16="http://schemas.microsoft.com/office/drawing/2014/main" id="{98422B35-CA7A-4098-8724-999F652D3672}"/>
+                <a16:creationId xmlns:a16="http://schemas.microsoft.com/office/drawing/2014/main" id="{058C8609-58B4-470F-9E15-935C7F89AEF0}"/>
               </a:ext>
             </a:extLst>
           </p:cNvPr>
@@ -10553,7 +10502,7 @@
           <p:cNvPr id="8" name="text">
             <a:extLst xmlns:a="http://schemas.openxmlformats.org/drawingml/2006/main">
               <a:ext uri="{FF2B5EF4-FFF2-40B4-BE49-F238E27FC236}">
-                <a16:creationId xmlns:a16="http://schemas.microsoft.com/office/drawing/2014/main" id="{A034A8F1-307A-4410-8A4B-58DEE3D53D24}"/>
+                <a16:creationId xmlns:a16="http://schemas.microsoft.com/office/drawing/2014/main" id="{D7F12CC4-1FA3-4D65-9FE8-BCC2D5C79897}"/>
               </a:ext>
             </a:extLst>
           </p:cNvPr>
@@ -10610,7 +10559,7 @@
           <p:cNvPr id="9" name="text">
             <a:extLst xmlns:a="http://schemas.openxmlformats.org/drawingml/2006/main">
               <a:ext uri="{FF2B5EF4-FFF2-40B4-BE49-F238E27FC236}">
-                <a16:creationId xmlns:a16="http://schemas.microsoft.com/office/drawing/2014/main" id="{F30CB452-CDF7-4D8E-A813-164E280C9279}"/>
+                <a16:creationId xmlns:a16="http://schemas.microsoft.com/office/drawing/2014/main" id="{5F87E4F9-510A-4222-8416-6B8E0E2671A2}"/>
               </a:ext>
             </a:extLst>
           </p:cNvPr>
@@ -10667,7 +10616,7 @@
           <p:cNvPr id="10" name="text">
             <a:extLst xmlns:a="http://schemas.openxmlformats.org/drawingml/2006/main">
               <a:ext uri="{FF2B5EF4-FFF2-40B4-BE49-F238E27FC236}">
-                <a16:creationId xmlns:a16="http://schemas.microsoft.com/office/drawing/2014/main" id="{ED52B036-0250-49C2-8676-F4D4CAD7A4D4}"/>
+                <a16:creationId xmlns:a16="http://schemas.microsoft.com/office/drawing/2014/main" id="{037C13ED-057D-4965-B0CA-2FC886B3F64A}"/>
               </a:ext>
             </a:extLst>
           </p:cNvPr>
@@ -10724,7 +10673,7 @@
           <p:cNvPr id="11" name="text">
             <a:extLst xmlns:a="http://schemas.openxmlformats.org/drawingml/2006/main">
               <a:ext uri="{FF2B5EF4-FFF2-40B4-BE49-F238E27FC236}">
-                <a16:creationId xmlns:a16="http://schemas.microsoft.com/office/drawing/2014/main" id="{A4222D27-E9B3-4028-AEA9-6A65784EFE8B}"/>
+                <a16:creationId xmlns:a16="http://schemas.microsoft.com/office/drawing/2014/main" id="{2EDD0FFB-373B-456C-A697-66133E337380}"/>
               </a:ext>
             </a:extLst>
           </p:cNvPr>
@@ -10779,7 +10728,7 @@
     </p:spTree>
     <p:extLst>
       <p:ext uri="{BB962C8B-B14F-4D97-AF65-F5344CB8AC3E}">
-        <p14:creationId xmlns:p14="http://schemas.microsoft.com/office/powerpoint/2010/main" val="963248597"/>
+        <p14:creationId xmlns:p14="http://schemas.microsoft.com/office/powerpoint/2010/main" val="1549688585"/>
       </p:ext>
     </p:extLst>
   </p:cSld>
@@ -10810,7 +10759,7 @@
           <p:cNvPr id="13" name="course">
             <a:extLst xmlns:a="http://schemas.openxmlformats.org/drawingml/2006/main">
               <a:ext uri="{FF2B5EF4-FFF2-40B4-BE49-F238E27FC236}">
-                <a16:creationId xmlns:a16="http://schemas.microsoft.com/office/drawing/2014/main" id="{5FC33377-4D47-4943-B60C-2997FB772D5F}"/>
+                <a16:creationId xmlns:a16="http://schemas.microsoft.com/office/drawing/2014/main" id="{18BCE9DF-2F04-4E35-8BE2-C68CFA72D0B7}"/>
               </a:ext>
             </a:extLst>
           </p:cNvPr>
@@ -10867,7 +10816,7 @@
           <p:cNvPr id="2" name="title">
             <a:extLst xmlns:a="http://schemas.openxmlformats.org/drawingml/2006/main">
               <a:ext uri="{FF2B5EF4-FFF2-40B4-BE49-F238E27FC236}">
-                <a16:creationId xmlns:a16="http://schemas.microsoft.com/office/drawing/2014/main" id="{B9D4EDEC-15E9-4AFF-B6F3-9338D259D802}"/>
+                <a16:creationId xmlns:a16="http://schemas.microsoft.com/office/drawing/2014/main" id="{B0555774-86BA-4D15-B0A0-4D42D14CE7D1}"/>
               </a:ext>
             </a:extLst>
           </p:cNvPr>
@@ -10924,7 +10873,7 @@
           <p:cNvPr id="3" name="page">
             <a:extLst xmlns:a="http://schemas.openxmlformats.org/drawingml/2006/main">
               <a:ext uri="{FF2B5EF4-FFF2-40B4-BE49-F238E27FC236}">
-                <a16:creationId xmlns:a16="http://schemas.microsoft.com/office/drawing/2014/main" id="{A26F9655-DB98-47F9-ACD3-F576A9B6F6FF}"/>
+                <a16:creationId xmlns:a16="http://schemas.microsoft.com/office/drawing/2014/main" id="{F0918913-4DE6-4A03-9749-9B786895C2ED}"/>
               </a:ext>
             </a:extLst>
           </p:cNvPr>
@@ -10981,7 +10930,7 @@
           <p:cNvPr id="4" name="text">
             <a:extLst xmlns:a="http://schemas.openxmlformats.org/drawingml/2006/main">
               <a:ext uri="{FF2B5EF4-FFF2-40B4-BE49-F238E27FC236}">
-                <a16:creationId xmlns:a16="http://schemas.microsoft.com/office/drawing/2014/main" id="{771EF924-4453-440E-BC15-7E612D145BDF}"/>
+                <a16:creationId xmlns:a16="http://schemas.microsoft.com/office/drawing/2014/main" id="{C3A1EFB7-B807-4FFE-9A92-12952A7A576A}"/>
               </a:ext>
             </a:extLst>
           </p:cNvPr>
@@ -11038,7 +10987,7 @@
           <p:cNvPr id="5" name="text">
             <a:extLst xmlns:a="http://schemas.openxmlformats.org/drawingml/2006/main">
               <a:ext uri="{FF2B5EF4-FFF2-40B4-BE49-F238E27FC236}">
-                <a16:creationId xmlns:a16="http://schemas.microsoft.com/office/drawing/2014/main" id="{EAC44125-8D67-478D-99C5-29201433A6B6}"/>
+                <a16:creationId xmlns:a16="http://schemas.microsoft.com/office/drawing/2014/main" id="{E9D5E372-7C87-4F83-9F25-695814F84279}"/>
               </a:ext>
             </a:extLst>
           </p:cNvPr>
@@ -11095,7 +11044,7 @@
           <p:cNvPr id="6" name="text">
             <a:extLst xmlns:a="http://schemas.openxmlformats.org/drawingml/2006/main">
               <a:ext uri="{FF2B5EF4-FFF2-40B4-BE49-F238E27FC236}">
-                <a16:creationId xmlns:a16="http://schemas.microsoft.com/office/drawing/2014/main" id="{9C411CA9-5515-45D9-9251-84086A9EAC95}"/>
+                <a16:creationId xmlns:a16="http://schemas.microsoft.com/office/drawing/2014/main" id="{89B46BE1-09F0-4B19-AB56-3F075B8D9414}"/>
               </a:ext>
             </a:extLst>
           </p:cNvPr>
@@ -11152,7 +11101,7 @@
           <p:cNvPr id="7" name="text">
             <a:extLst xmlns:a="http://schemas.openxmlformats.org/drawingml/2006/main">
               <a:ext uri="{FF2B5EF4-FFF2-40B4-BE49-F238E27FC236}">
-                <a16:creationId xmlns:a16="http://schemas.microsoft.com/office/drawing/2014/main" id="{7A146079-9768-47E7-8F7A-89794499DB9A}"/>
+                <a16:creationId xmlns:a16="http://schemas.microsoft.com/office/drawing/2014/main" id="{4C62C89B-E7BB-4DED-BEEA-8153DC2568B0}"/>
               </a:ext>
             </a:extLst>
           </p:cNvPr>
@@ -11209,7 +11158,7 @@
           <p:cNvPr id="8" name="text">
             <a:extLst xmlns:a="http://schemas.openxmlformats.org/drawingml/2006/main">
               <a:ext uri="{FF2B5EF4-FFF2-40B4-BE49-F238E27FC236}">
-                <a16:creationId xmlns:a16="http://schemas.microsoft.com/office/drawing/2014/main" id="{DE5D4EE9-89B0-458D-92F8-5129AEDFE9E4}"/>
+                <a16:creationId xmlns:a16="http://schemas.microsoft.com/office/drawing/2014/main" id="{A37BD46F-029B-4C21-8F96-0B90A96960BD}"/>
               </a:ext>
             </a:extLst>
           </p:cNvPr>
@@ -11266,7 +11215,7 @@
           <p:cNvPr id="9" name="text">
             <a:extLst xmlns:a="http://schemas.openxmlformats.org/drawingml/2006/main">
               <a:ext uri="{FF2B5EF4-FFF2-40B4-BE49-F238E27FC236}">
-                <a16:creationId xmlns:a16="http://schemas.microsoft.com/office/drawing/2014/main" id="{5287F734-2833-4560-9881-9797A5D4DAF8}"/>
+                <a16:creationId xmlns:a16="http://schemas.microsoft.com/office/drawing/2014/main" id="{63C866AE-3240-43CC-ABE2-34F4CF927A01}"/>
               </a:ext>
             </a:extLst>
           </p:cNvPr>
@@ -11323,7 +11272,7 @@
           <p:cNvPr id="10" name="text">
             <a:extLst xmlns:a="http://schemas.openxmlformats.org/drawingml/2006/main">
               <a:ext uri="{FF2B5EF4-FFF2-40B4-BE49-F238E27FC236}">
-                <a16:creationId xmlns:a16="http://schemas.microsoft.com/office/drawing/2014/main" id="{A4062D26-48BC-46B2-B3D4-412BA0F2EAA7}"/>
+                <a16:creationId xmlns:a16="http://schemas.microsoft.com/office/drawing/2014/main" id="{067CF665-A993-4F52-AB75-7386329EFA46}"/>
               </a:ext>
             </a:extLst>
           </p:cNvPr>
@@ -11380,7 +11329,7 @@
           <p:cNvPr id="11" name="text">
             <a:extLst xmlns:a="http://schemas.openxmlformats.org/drawingml/2006/main">
               <a:ext uri="{FF2B5EF4-FFF2-40B4-BE49-F238E27FC236}">
-                <a16:creationId xmlns:a16="http://schemas.microsoft.com/office/drawing/2014/main" id="{445DBFE5-67B1-45C5-B83E-C4F1A6F174BA}"/>
+                <a16:creationId xmlns:a16="http://schemas.microsoft.com/office/drawing/2014/main" id="{D2ADFB01-0D9D-4FBF-B69A-8784D2DEDFBC}"/>
               </a:ext>
             </a:extLst>
           </p:cNvPr>
@@ -11437,7 +11386,7 @@
           <p:cNvPr id="12" name="text">
             <a:extLst xmlns:a="http://schemas.openxmlformats.org/drawingml/2006/main">
               <a:ext uri="{FF2B5EF4-FFF2-40B4-BE49-F238E27FC236}">
-                <a16:creationId xmlns:a16="http://schemas.microsoft.com/office/drawing/2014/main" id="{801D1EDE-CDF7-4A29-A5E5-918655E3B95D}"/>
+                <a16:creationId xmlns:a16="http://schemas.microsoft.com/office/drawing/2014/main" id="{C47AE377-FD52-455B-8816-FA9DE29DA66B}"/>
               </a:ext>
             </a:extLst>
           </p:cNvPr>
@@ -11492,7 +11441,7 @@
     </p:spTree>
     <p:extLst>
       <p:ext uri="{BB962C8B-B14F-4D97-AF65-F5344CB8AC3E}">
-        <p14:creationId xmlns:p14="http://schemas.microsoft.com/office/powerpoint/2010/main" val="1482042371"/>
+        <p14:creationId xmlns:p14="http://schemas.microsoft.com/office/powerpoint/2010/main" val="1519689381"/>
       </p:ext>
     </p:extLst>
   </p:cSld>
@@ -11523,7 +11472,7 @@
           <p:cNvPr id="10" name="course">
             <a:extLst xmlns:a="http://schemas.openxmlformats.org/drawingml/2006/main">
               <a:ext uri="{FF2B5EF4-FFF2-40B4-BE49-F238E27FC236}">
-                <a16:creationId xmlns:a16="http://schemas.microsoft.com/office/drawing/2014/main" id="{3A6C53AE-E9AC-41FC-A0AC-AA480067166E}"/>
+                <a16:creationId xmlns:a16="http://schemas.microsoft.com/office/drawing/2014/main" id="{5161F60D-8E53-4482-8401-A698D42F35F4}"/>
               </a:ext>
             </a:extLst>
           </p:cNvPr>
@@ -11580,7 +11529,7 @@
           <p:cNvPr id="2" name="title">
             <a:extLst xmlns:a="http://schemas.openxmlformats.org/drawingml/2006/main">
               <a:ext uri="{FF2B5EF4-FFF2-40B4-BE49-F238E27FC236}">
-                <a16:creationId xmlns:a16="http://schemas.microsoft.com/office/drawing/2014/main" id="{3EACD36F-2AB2-459F-9E2F-7B607DB9C1E9}"/>
+                <a16:creationId xmlns:a16="http://schemas.microsoft.com/office/drawing/2014/main" id="{83587500-EC27-4018-85F7-895C55DC430D}"/>
               </a:ext>
             </a:extLst>
           </p:cNvPr>
@@ -11637,7 +11586,7 @@
           <p:cNvPr id="3" name="page">
             <a:extLst xmlns:a="http://schemas.openxmlformats.org/drawingml/2006/main">
               <a:ext uri="{FF2B5EF4-FFF2-40B4-BE49-F238E27FC236}">
-                <a16:creationId xmlns:a16="http://schemas.microsoft.com/office/drawing/2014/main" id="{D7567DD5-C323-4CCD-BAFF-B834AFCE64D7}"/>
+                <a16:creationId xmlns:a16="http://schemas.microsoft.com/office/drawing/2014/main" id="{0B19483D-EB2D-4B00-908A-26568CB04293}"/>
               </a:ext>
             </a:extLst>
           </p:cNvPr>
@@ -11694,7 +11643,7 @@
           <p:cNvPr id="4" name="text">
             <a:extLst xmlns:a="http://schemas.openxmlformats.org/drawingml/2006/main">
               <a:ext uri="{FF2B5EF4-FFF2-40B4-BE49-F238E27FC236}">
-                <a16:creationId xmlns:a16="http://schemas.microsoft.com/office/drawing/2014/main" id="{3A709A2F-BE70-4EE6-B926-5D67DC9DEE47}"/>
+                <a16:creationId xmlns:a16="http://schemas.microsoft.com/office/drawing/2014/main" id="{1F572849-B4BD-4896-B9C1-2B8F1BC011AB}"/>
               </a:ext>
             </a:extLst>
           </p:cNvPr>
@@ -11751,7 +11700,7 @@
           <p:cNvPr id="5" name="text">
             <a:extLst xmlns:a="http://schemas.openxmlformats.org/drawingml/2006/main">
               <a:ext uri="{FF2B5EF4-FFF2-40B4-BE49-F238E27FC236}">
-                <a16:creationId xmlns:a16="http://schemas.microsoft.com/office/drawing/2014/main" id="{A5AFB3B0-F6CF-4DE6-A9BE-7477B934650E}"/>
+                <a16:creationId xmlns:a16="http://schemas.microsoft.com/office/drawing/2014/main" id="{A1A0AB64-3B64-47C4-964F-F3CBEDE2DB8E}"/>
               </a:ext>
             </a:extLst>
           </p:cNvPr>
@@ -11808,7 +11757,7 @@
           <p:cNvPr id="6" name="text">
             <a:extLst xmlns:a="http://schemas.openxmlformats.org/drawingml/2006/main">
               <a:ext uri="{FF2B5EF4-FFF2-40B4-BE49-F238E27FC236}">
-                <a16:creationId xmlns:a16="http://schemas.microsoft.com/office/drawing/2014/main" id="{61BAFC7A-BD1F-458C-A325-1B1B20D2D332}"/>
+                <a16:creationId xmlns:a16="http://schemas.microsoft.com/office/drawing/2014/main" id="{FE20050E-FF54-4AC4-80F2-10B9E2B57315}"/>
               </a:ext>
             </a:extLst>
           </p:cNvPr>
@@ -11865,7 +11814,7 @@
           <p:cNvPr id="7" name="text">
             <a:extLst xmlns:a="http://schemas.openxmlformats.org/drawingml/2006/main">
               <a:ext uri="{FF2B5EF4-FFF2-40B4-BE49-F238E27FC236}">
-                <a16:creationId xmlns:a16="http://schemas.microsoft.com/office/drawing/2014/main" id="{C186342F-C26E-4B19-BFA3-4C86DF6F287C}"/>
+                <a16:creationId xmlns:a16="http://schemas.microsoft.com/office/drawing/2014/main" id="{E97B3C02-BF7A-4042-B007-E8E0C5595928}"/>
               </a:ext>
             </a:extLst>
           </p:cNvPr>
@@ -11922,7 +11871,7 @@
           <p:cNvPr id="8" name="text">
             <a:extLst xmlns:a="http://schemas.openxmlformats.org/drawingml/2006/main">
               <a:ext uri="{FF2B5EF4-FFF2-40B4-BE49-F238E27FC236}">
-                <a16:creationId xmlns:a16="http://schemas.microsoft.com/office/drawing/2014/main" id="{BCB70E3B-FF49-4A16-92F1-6DCD915FA62D}"/>
+                <a16:creationId xmlns:a16="http://schemas.microsoft.com/office/drawing/2014/main" id="{167C2361-EC24-4448-85CA-05EB70A473D3}"/>
               </a:ext>
             </a:extLst>
           </p:cNvPr>
@@ -11979,7 +11928,7 @@
           <p:cNvPr id="9" name="text">
             <a:extLst xmlns:a="http://schemas.openxmlformats.org/drawingml/2006/main">
               <a:ext uri="{FF2B5EF4-FFF2-40B4-BE49-F238E27FC236}">
-                <a16:creationId xmlns:a16="http://schemas.microsoft.com/office/drawing/2014/main" id="{F2BE0B91-E1E3-4BB8-87B0-CBC57EA43B37}"/>
+                <a16:creationId xmlns:a16="http://schemas.microsoft.com/office/drawing/2014/main" id="{5F5B95EB-6BB2-4951-A52A-045CCF96E055}"/>
               </a:ext>
             </a:extLst>
           </p:cNvPr>
@@ -12034,7 +11983,7 @@
     </p:spTree>
     <p:extLst>
       <p:ext uri="{BB962C8B-B14F-4D97-AF65-F5344CB8AC3E}">
-        <p14:creationId xmlns:p14="http://schemas.microsoft.com/office/powerpoint/2010/main" val="1172222158"/>
+        <p14:creationId xmlns:p14="http://schemas.microsoft.com/office/powerpoint/2010/main" val="2074196964"/>
       </p:ext>
     </p:extLst>
   </p:cSld>
@@ -12065,7 +12014,7 @@
           <p:cNvPr id="10" name="course">
             <a:extLst xmlns:a="http://schemas.openxmlformats.org/drawingml/2006/main">
               <a:ext uri="{FF2B5EF4-FFF2-40B4-BE49-F238E27FC236}">
-                <a16:creationId xmlns:a16="http://schemas.microsoft.com/office/drawing/2014/main" id="{5F058ECD-F51F-4C81-A720-C1D08C841C31}"/>
+                <a16:creationId xmlns:a16="http://schemas.microsoft.com/office/drawing/2014/main" id="{995476E4-27D7-42CF-9C14-5F4E964E48A8}"/>
               </a:ext>
             </a:extLst>
           </p:cNvPr>
@@ -12122,7 +12071,7 @@
           <p:cNvPr id="2" name="title">
             <a:extLst xmlns:a="http://schemas.openxmlformats.org/drawingml/2006/main">
               <a:ext uri="{FF2B5EF4-FFF2-40B4-BE49-F238E27FC236}">
-                <a16:creationId xmlns:a16="http://schemas.microsoft.com/office/drawing/2014/main" id="{A5E3B66F-A7DD-4679-9840-1B991C2CE036}"/>
+                <a16:creationId xmlns:a16="http://schemas.microsoft.com/office/drawing/2014/main" id="{E5F4FD57-256E-47DF-820A-059196F14959}"/>
               </a:ext>
             </a:extLst>
           </p:cNvPr>
@@ -12179,7 +12128,7 @@
           <p:cNvPr id="3" name="page">
             <a:extLst xmlns:a="http://schemas.openxmlformats.org/drawingml/2006/main">
               <a:ext uri="{FF2B5EF4-FFF2-40B4-BE49-F238E27FC236}">
-                <a16:creationId xmlns:a16="http://schemas.microsoft.com/office/drawing/2014/main" id="{0095FC5E-C0CB-429E-8CB8-9FA00BE73215}"/>
+                <a16:creationId xmlns:a16="http://schemas.microsoft.com/office/drawing/2014/main" id="{26279580-BA9E-4D88-89E6-D69D2455B739}"/>
               </a:ext>
             </a:extLst>
           </p:cNvPr>
@@ -12236,7 +12185,7 @@
           <p:cNvPr id="4" name="text">
             <a:extLst xmlns:a="http://schemas.openxmlformats.org/drawingml/2006/main">
               <a:ext uri="{FF2B5EF4-FFF2-40B4-BE49-F238E27FC236}">
-                <a16:creationId xmlns:a16="http://schemas.microsoft.com/office/drawing/2014/main" id="{8DCBF2AB-28DD-4FE0-8113-0E983A20399B}"/>
+                <a16:creationId xmlns:a16="http://schemas.microsoft.com/office/drawing/2014/main" id="{E6F0EF37-B837-433B-9A32-48ED3ABA48E8}"/>
               </a:ext>
             </a:extLst>
           </p:cNvPr>
@@ -12293,7 +12242,7 @@
           <p:cNvPr id="5" name="text">
             <a:extLst xmlns:a="http://schemas.openxmlformats.org/drawingml/2006/main">
               <a:ext uri="{FF2B5EF4-FFF2-40B4-BE49-F238E27FC236}">
-                <a16:creationId xmlns:a16="http://schemas.microsoft.com/office/drawing/2014/main" id="{DCF41874-C411-4969-9742-384275E1CF42}"/>
+                <a16:creationId xmlns:a16="http://schemas.microsoft.com/office/drawing/2014/main" id="{4B6F7460-F4F6-4865-A40D-EE8FA3C8C138}"/>
               </a:ext>
             </a:extLst>
           </p:cNvPr>
@@ -12350,7 +12299,7 @@
           <p:cNvPr id="6" name="text">
             <a:extLst xmlns:a="http://schemas.openxmlformats.org/drawingml/2006/main">
               <a:ext uri="{FF2B5EF4-FFF2-40B4-BE49-F238E27FC236}">
-                <a16:creationId xmlns:a16="http://schemas.microsoft.com/office/drawing/2014/main" id="{C01E0403-33C0-47B0-B1CE-CFCD2BE57610}"/>
+                <a16:creationId xmlns:a16="http://schemas.microsoft.com/office/drawing/2014/main" id="{51E0C151-7BA4-4B2C-921F-8ABF99E0C3FF}"/>
               </a:ext>
             </a:extLst>
           </p:cNvPr>
@@ -12407,7 +12356,7 @@
           <p:cNvPr id="7" name="text">
             <a:extLst xmlns:a="http://schemas.openxmlformats.org/drawingml/2006/main">
               <a:ext uri="{FF2B5EF4-FFF2-40B4-BE49-F238E27FC236}">
-                <a16:creationId xmlns:a16="http://schemas.microsoft.com/office/drawing/2014/main" id="{89BEB10E-6C49-4B51-9D5E-33D6E1E86BDF}"/>
+                <a16:creationId xmlns:a16="http://schemas.microsoft.com/office/drawing/2014/main" id="{BFFDCFC5-4D23-43C6-9077-D93EE943B4AC}"/>
               </a:ext>
             </a:extLst>
           </p:cNvPr>
@@ -12464,7 +12413,7 @@
           <p:cNvPr id="8" name="text">
             <a:extLst xmlns:a="http://schemas.openxmlformats.org/drawingml/2006/main">
               <a:ext uri="{FF2B5EF4-FFF2-40B4-BE49-F238E27FC236}">
-                <a16:creationId xmlns:a16="http://schemas.microsoft.com/office/drawing/2014/main" id="{2699E270-7347-4992-9D62-DCFC361CDEB7}"/>
+                <a16:creationId xmlns:a16="http://schemas.microsoft.com/office/drawing/2014/main" id="{1AD8F7EF-F628-4E1F-BCEE-72CE5BA32C46}"/>
               </a:ext>
             </a:extLst>
           </p:cNvPr>
@@ -12521,7 +12470,7 @@
           <p:cNvPr id="9" name="text">
             <a:extLst xmlns:a="http://schemas.openxmlformats.org/drawingml/2006/main">
               <a:ext uri="{FF2B5EF4-FFF2-40B4-BE49-F238E27FC236}">
-                <a16:creationId xmlns:a16="http://schemas.microsoft.com/office/drawing/2014/main" id="{E18722BA-A418-4C99-BD9E-BFED7BC86F59}"/>
+                <a16:creationId xmlns:a16="http://schemas.microsoft.com/office/drawing/2014/main" id="{88B3C64B-FE14-4ABF-98E2-70FA12DDCC5F}"/>
               </a:ext>
             </a:extLst>
           </p:cNvPr>
@@ -12576,7 +12525,7 @@
     </p:spTree>
     <p:extLst>
       <p:ext uri="{BB962C8B-B14F-4D97-AF65-F5344CB8AC3E}">
-        <p14:creationId xmlns:p14="http://schemas.microsoft.com/office/powerpoint/2010/main" val="202896178"/>
+        <p14:creationId xmlns:p14="http://schemas.microsoft.com/office/powerpoint/2010/main" val="1114766798"/>
       </p:ext>
     </p:extLst>
   </p:cSld>
@@ -12607,7 +12556,7 @@
           <p:cNvPr id="12" name="course">
             <a:extLst xmlns:a="http://schemas.openxmlformats.org/drawingml/2006/main">
               <a:ext uri="{FF2B5EF4-FFF2-40B4-BE49-F238E27FC236}">
-                <a16:creationId xmlns:a16="http://schemas.microsoft.com/office/drawing/2014/main" id="{69ED3DF2-FD61-4D0B-B0C3-6D47CF491197}"/>
+                <a16:creationId xmlns:a16="http://schemas.microsoft.com/office/drawing/2014/main" id="{A59A0FC6-86AD-4C64-AD22-9EDFB6ED15D0}"/>
               </a:ext>
             </a:extLst>
           </p:cNvPr>
@@ -12664,7 +12613,7 @@
           <p:cNvPr id="2" name="title">
             <a:extLst xmlns:a="http://schemas.openxmlformats.org/drawingml/2006/main">
               <a:ext uri="{FF2B5EF4-FFF2-40B4-BE49-F238E27FC236}">
-                <a16:creationId xmlns:a16="http://schemas.microsoft.com/office/drawing/2014/main" id="{13C06046-88D4-469D-B2D1-B03826A951AC}"/>
+                <a16:creationId xmlns:a16="http://schemas.microsoft.com/office/drawing/2014/main" id="{AFE3B5FC-1B6A-43B4-8BF1-5B5CFF84FF60}"/>
               </a:ext>
             </a:extLst>
           </p:cNvPr>
@@ -12721,7 +12670,7 @@
           <p:cNvPr id="3" name="page">
             <a:extLst xmlns:a="http://schemas.openxmlformats.org/drawingml/2006/main">
               <a:ext uri="{FF2B5EF4-FFF2-40B4-BE49-F238E27FC236}">
-                <a16:creationId xmlns:a16="http://schemas.microsoft.com/office/drawing/2014/main" id="{1643F518-4324-425E-863F-0025FED0EA07}"/>
+                <a16:creationId xmlns:a16="http://schemas.microsoft.com/office/drawing/2014/main" id="{9F862273-C277-42FC-A37F-9ACD79DED385}"/>
               </a:ext>
             </a:extLst>
           </p:cNvPr>
@@ -12778,7 +12727,7 @@
           <p:cNvPr id="4" name="text">
             <a:extLst xmlns:a="http://schemas.openxmlformats.org/drawingml/2006/main">
               <a:ext uri="{FF2B5EF4-FFF2-40B4-BE49-F238E27FC236}">
-                <a16:creationId xmlns:a16="http://schemas.microsoft.com/office/drawing/2014/main" id="{2FEE931B-75CE-4354-B83F-CAAD57721B14}"/>
+                <a16:creationId xmlns:a16="http://schemas.microsoft.com/office/drawing/2014/main" id="{F51655F0-CBF2-4B17-8590-E5DB84E0B162}"/>
               </a:ext>
             </a:extLst>
           </p:cNvPr>
@@ -12835,7 +12784,7 @@
           <p:cNvPr id="5" name="text">
             <a:extLst xmlns:a="http://schemas.openxmlformats.org/drawingml/2006/main">
               <a:ext uri="{FF2B5EF4-FFF2-40B4-BE49-F238E27FC236}">
-                <a16:creationId xmlns:a16="http://schemas.microsoft.com/office/drawing/2014/main" id="{3BF3AC94-E931-4F9E-921B-0403A1CC27D8}"/>
+                <a16:creationId xmlns:a16="http://schemas.microsoft.com/office/drawing/2014/main" id="{19851FB0-3C6D-4648-BB68-B9E9F7702681}"/>
               </a:ext>
             </a:extLst>
           </p:cNvPr>
@@ -12892,7 +12841,7 @@
           <p:cNvPr id="6" name="text">
             <a:extLst xmlns:a="http://schemas.openxmlformats.org/drawingml/2006/main">
               <a:ext uri="{FF2B5EF4-FFF2-40B4-BE49-F238E27FC236}">
-                <a16:creationId xmlns:a16="http://schemas.microsoft.com/office/drawing/2014/main" id="{360880CA-9BDC-4CE2-A2B0-67E1199F8513}"/>
+                <a16:creationId xmlns:a16="http://schemas.microsoft.com/office/drawing/2014/main" id="{5463379E-3992-44A4-A363-FABED6909FA0}"/>
               </a:ext>
             </a:extLst>
           </p:cNvPr>
@@ -12949,7 +12898,7 @@
           <p:cNvPr id="7" name="text">
             <a:extLst xmlns:a="http://schemas.openxmlformats.org/drawingml/2006/main">
               <a:ext uri="{FF2B5EF4-FFF2-40B4-BE49-F238E27FC236}">
-                <a16:creationId xmlns:a16="http://schemas.microsoft.com/office/drawing/2014/main" id="{3D0ECC41-E2E5-4911-AFA2-55F5E7270AB5}"/>
+                <a16:creationId xmlns:a16="http://schemas.microsoft.com/office/drawing/2014/main" id="{3E0CEFFF-84AE-4DFD-811E-2E6809354881}"/>
               </a:ext>
             </a:extLst>
           </p:cNvPr>
@@ -13006,7 +12955,7 @@
           <p:cNvPr id="8" name="text">
             <a:extLst xmlns:a="http://schemas.openxmlformats.org/drawingml/2006/main">
               <a:ext uri="{FF2B5EF4-FFF2-40B4-BE49-F238E27FC236}">
-                <a16:creationId xmlns:a16="http://schemas.microsoft.com/office/drawing/2014/main" id="{7B30964A-36AA-4E04-B50F-0C23295826AF}"/>
+                <a16:creationId xmlns:a16="http://schemas.microsoft.com/office/drawing/2014/main" id="{2DED8EB3-AE47-47F2-BBD5-9363A578AFF2}"/>
               </a:ext>
             </a:extLst>
           </p:cNvPr>
@@ -13063,7 +13012,7 @@
           <p:cNvPr id="9" name="text">
             <a:extLst xmlns:a="http://schemas.openxmlformats.org/drawingml/2006/main">
               <a:ext uri="{FF2B5EF4-FFF2-40B4-BE49-F238E27FC236}">
-                <a16:creationId xmlns:a16="http://schemas.microsoft.com/office/drawing/2014/main" id="{2B38C4D0-046D-4F50-9571-5DD33AC137AB}"/>
+                <a16:creationId xmlns:a16="http://schemas.microsoft.com/office/drawing/2014/main" id="{13C318ED-1700-4C53-B482-7AC853AD5D02}"/>
               </a:ext>
             </a:extLst>
           </p:cNvPr>
@@ -13120,7 +13069,7 @@
           <p:cNvPr id="10" name="text">
             <a:extLst xmlns:a="http://schemas.openxmlformats.org/drawingml/2006/main">
               <a:ext uri="{FF2B5EF4-FFF2-40B4-BE49-F238E27FC236}">
-                <a16:creationId xmlns:a16="http://schemas.microsoft.com/office/drawing/2014/main" id="{2251A8FD-895D-41A8-811A-FD00425530FA}"/>
+                <a16:creationId xmlns:a16="http://schemas.microsoft.com/office/drawing/2014/main" id="{59938CD1-84B6-48D3-A891-A8B4274D2483}"/>
               </a:ext>
             </a:extLst>
           </p:cNvPr>
@@ -13177,7 +13126,7 @@
           <p:cNvPr id="11" name="text">
             <a:extLst xmlns:a="http://schemas.openxmlformats.org/drawingml/2006/main">
               <a:ext uri="{FF2B5EF4-FFF2-40B4-BE49-F238E27FC236}">
-                <a16:creationId xmlns:a16="http://schemas.microsoft.com/office/drawing/2014/main" id="{F4310011-5658-4DCD-BD09-620522C76544}"/>
+                <a16:creationId xmlns:a16="http://schemas.microsoft.com/office/drawing/2014/main" id="{2FE46551-6BB1-4A81-B520-CEC8739EE914}"/>
               </a:ext>
             </a:extLst>
           </p:cNvPr>
@@ -13232,7 +13181,7 @@
     </p:spTree>
     <p:extLst>
       <p:ext uri="{BB962C8B-B14F-4D97-AF65-F5344CB8AC3E}">
-        <p14:creationId xmlns:p14="http://schemas.microsoft.com/office/powerpoint/2010/main" val="1737427035"/>
+        <p14:creationId xmlns:p14="http://schemas.microsoft.com/office/powerpoint/2010/main" val="1686289337"/>
       </p:ext>
     </p:extLst>
   </p:cSld>
@@ -13263,7 +13212,7 @@
           <p:cNvPr id="6" name="course">
             <a:extLst xmlns:a="http://schemas.openxmlformats.org/drawingml/2006/main">
               <a:ext uri="{FF2B5EF4-FFF2-40B4-BE49-F238E27FC236}">
-                <a16:creationId xmlns:a16="http://schemas.microsoft.com/office/drawing/2014/main" id="{06DE1DC0-AD79-46FB-B738-9AB0B69945E4}"/>
+                <a16:creationId xmlns:a16="http://schemas.microsoft.com/office/drawing/2014/main" id="{EAEB55CB-E081-4D93-A3C7-594909FF1033}"/>
               </a:ext>
             </a:extLst>
           </p:cNvPr>
@@ -13320,7 +13269,7 @@
           <p:cNvPr id="2" name="title">
             <a:extLst xmlns:a="http://schemas.openxmlformats.org/drawingml/2006/main">
               <a:ext uri="{FF2B5EF4-FFF2-40B4-BE49-F238E27FC236}">
-                <a16:creationId xmlns:a16="http://schemas.microsoft.com/office/drawing/2014/main" id="{66D12F69-E72B-426A-BFF4-A1F085648C48}"/>
+                <a16:creationId xmlns:a16="http://schemas.microsoft.com/office/drawing/2014/main" id="{CEBE8D37-F16A-4A4F-B350-E8D5AA65B6E4}"/>
               </a:ext>
             </a:extLst>
           </p:cNvPr>
@@ -13377,7 +13326,7 @@
           <p:cNvPr id="3" name="page">
             <a:extLst xmlns:a="http://schemas.openxmlformats.org/drawingml/2006/main">
               <a:ext uri="{FF2B5EF4-FFF2-40B4-BE49-F238E27FC236}">
-                <a16:creationId xmlns:a16="http://schemas.microsoft.com/office/drawing/2014/main" id="{498DD163-A60C-4F5B-853E-7C05A47D8A87}"/>
+                <a16:creationId xmlns:a16="http://schemas.microsoft.com/office/drawing/2014/main" id="{11E2FCAA-9E36-4A97-80A6-D84E24B51996}"/>
               </a:ext>
             </a:extLst>
           </p:cNvPr>
@@ -13434,7 +13383,7 @@
           <p:cNvPr id="4" name="code">
             <a:extLst xmlns:a="http://schemas.openxmlformats.org/drawingml/2006/main">
               <a:ext uri="{FF2B5EF4-FFF2-40B4-BE49-F238E27FC236}">
-                <a16:creationId xmlns:a16="http://schemas.microsoft.com/office/drawing/2014/main" id="{C666FF10-05FD-4F84-8535-0E64AED90F5A}"/>
+                <a16:creationId xmlns:a16="http://schemas.microsoft.com/office/drawing/2014/main" id="{16DFD505-D9D4-4889-A1BA-88B9754C90EB}"/>
               </a:ext>
             </a:extLst>
           </p:cNvPr>
@@ -13590,7 +13539,7 @@
           <p:cNvPr id="5" name="text">
             <a:extLst xmlns:a="http://schemas.openxmlformats.org/drawingml/2006/main">
               <a:ext uri="{FF2B5EF4-FFF2-40B4-BE49-F238E27FC236}">
-                <a16:creationId xmlns:a16="http://schemas.microsoft.com/office/drawing/2014/main" id="{C7ADE931-AFEC-49C0-8A7D-5C384F6B2554}"/>
+                <a16:creationId xmlns:a16="http://schemas.microsoft.com/office/drawing/2014/main" id="{1F8E44F3-0638-4896-B7A2-411A05A4D14D}"/>
               </a:ext>
             </a:extLst>
           </p:cNvPr>
@@ -13645,7 +13594,7 @@
     </p:spTree>
     <p:extLst>
       <p:ext uri="{BB962C8B-B14F-4D97-AF65-F5344CB8AC3E}">
-        <p14:creationId xmlns:p14="http://schemas.microsoft.com/office/powerpoint/2010/main" val="1433905789"/>
+        <p14:creationId xmlns:p14="http://schemas.microsoft.com/office/powerpoint/2010/main" val="463600250"/>
       </p:ext>
     </p:extLst>
   </p:cSld>
@@ -13676,7 +13625,7 @@
           <p:cNvPr id="6" name="course">
             <a:extLst xmlns:a="http://schemas.openxmlformats.org/drawingml/2006/main">
               <a:ext uri="{FF2B5EF4-FFF2-40B4-BE49-F238E27FC236}">
-                <a16:creationId xmlns:a16="http://schemas.microsoft.com/office/drawing/2014/main" id="{FE90B08F-6EB5-4C80-BC53-7042A651C9A2}"/>
+                <a16:creationId xmlns:a16="http://schemas.microsoft.com/office/drawing/2014/main" id="{133824A9-99B1-4801-BFAC-A6715A97CCF5}"/>
               </a:ext>
             </a:extLst>
           </p:cNvPr>
@@ -13733,7 +13682,7 @@
           <p:cNvPr id="2" name="title">
             <a:extLst xmlns:a="http://schemas.openxmlformats.org/drawingml/2006/main">
               <a:ext uri="{FF2B5EF4-FFF2-40B4-BE49-F238E27FC236}">
-                <a16:creationId xmlns:a16="http://schemas.microsoft.com/office/drawing/2014/main" id="{4583CBF5-6320-4119-9373-3500002384E7}"/>
+                <a16:creationId xmlns:a16="http://schemas.microsoft.com/office/drawing/2014/main" id="{41A8BA6F-A90A-4E75-B948-25CA12F7E737}"/>
               </a:ext>
             </a:extLst>
           </p:cNvPr>
@@ -13790,7 +13739,7 @@
           <p:cNvPr id="3" name="page">
             <a:extLst xmlns:a="http://schemas.openxmlformats.org/drawingml/2006/main">
               <a:ext uri="{FF2B5EF4-FFF2-40B4-BE49-F238E27FC236}">
-                <a16:creationId xmlns:a16="http://schemas.microsoft.com/office/drawing/2014/main" id="{2B8545B5-B0A1-47E1-8DA3-AE9B7F5C290A}"/>
+                <a16:creationId xmlns:a16="http://schemas.microsoft.com/office/drawing/2014/main" id="{5C483C04-472C-4747-9A31-8463AB8CA1F5}"/>
               </a:ext>
             </a:extLst>
           </p:cNvPr>
@@ -13847,7 +13796,7 @@
           <p:cNvPr id="4" name="code">
             <a:extLst xmlns:a="http://schemas.openxmlformats.org/drawingml/2006/main">
               <a:ext uri="{FF2B5EF4-FFF2-40B4-BE49-F238E27FC236}">
-                <a16:creationId xmlns:a16="http://schemas.microsoft.com/office/drawing/2014/main" id="{1A1157CF-33CF-4071-987A-8FF30020EF7E}"/>
+                <a16:creationId xmlns:a16="http://schemas.microsoft.com/office/drawing/2014/main" id="{A474F468-C44C-4EF7-98C8-0EF45A061CB3}"/>
               </a:ext>
             </a:extLst>
           </p:cNvPr>
@@ -14003,7 +13952,7 @@
           <p:cNvPr id="5" name="text">
             <a:extLst xmlns:a="http://schemas.openxmlformats.org/drawingml/2006/main">
               <a:ext uri="{FF2B5EF4-FFF2-40B4-BE49-F238E27FC236}">
-                <a16:creationId xmlns:a16="http://schemas.microsoft.com/office/drawing/2014/main" id="{1F9C3D71-09BA-48E6-9C3F-7944182E463D}"/>
+                <a16:creationId xmlns:a16="http://schemas.microsoft.com/office/drawing/2014/main" id="{B7BDFB4F-54E1-4085-980C-F1CE2E0C8B82}"/>
               </a:ext>
             </a:extLst>
           </p:cNvPr>
@@ -14058,7 +14007,7 @@
     </p:spTree>
     <p:extLst>
       <p:ext uri="{BB962C8B-B14F-4D97-AF65-F5344CB8AC3E}">
-        <p14:creationId xmlns:p14="http://schemas.microsoft.com/office/powerpoint/2010/main" val="2077292433"/>
+        <p14:creationId xmlns:p14="http://schemas.microsoft.com/office/powerpoint/2010/main" val="438000330"/>
       </p:ext>
     </p:extLst>
   </p:cSld>
@@ -14089,7 +14038,7 @@
           <p:cNvPr id="11" name="course">
             <a:extLst xmlns:a="http://schemas.openxmlformats.org/drawingml/2006/main">
               <a:ext uri="{FF2B5EF4-FFF2-40B4-BE49-F238E27FC236}">
-                <a16:creationId xmlns:a16="http://schemas.microsoft.com/office/drawing/2014/main" id="{87424C6D-9123-4314-9E7C-C7C5AE22F40A}"/>
+                <a16:creationId xmlns:a16="http://schemas.microsoft.com/office/drawing/2014/main" id="{581A9820-6375-4671-90D7-2F42266011E4}"/>
               </a:ext>
             </a:extLst>
           </p:cNvPr>
@@ -14146,7 +14095,7 @@
           <p:cNvPr id="2" name="title">
             <a:extLst xmlns:a="http://schemas.openxmlformats.org/drawingml/2006/main">
               <a:ext uri="{FF2B5EF4-FFF2-40B4-BE49-F238E27FC236}">
-                <a16:creationId xmlns:a16="http://schemas.microsoft.com/office/drawing/2014/main" id="{88BC5D19-CEDA-45FD-B083-975E53A79D53}"/>
+                <a16:creationId xmlns:a16="http://schemas.microsoft.com/office/drawing/2014/main" id="{55018F4E-016C-4721-95CB-85BC6BD49216}"/>
               </a:ext>
             </a:extLst>
           </p:cNvPr>
@@ -14203,7 +14152,7 @@
           <p:cNvPr id="3" name="page">
             <a:extLst xmlns:a="http://schemas.openxmlformats.org/drawingml/2006/main">
               <a:ext uri="{FF2B5EF4-FFF2-40B4-BE49-F238E27FC236}">
-                <a16:creationId xmlns:a16="http://schemas.microsoft.com/office/drawing/2014/main" id="{8192C4CA-FAEF-40FE-AEB7-2B2ACF058A84}"/>
+                <a16:creationId xmlns:a16="http://schemas.microsoft.com/office/drawing/2014/main" id="{24FF7C02-D2FF-4438-A0CC-448487F3CA77}"/>
               </a:ext>
             </a:extLst>
           </p:cNvPr>
@@ -14260,7 +14209,7 @@
           <p:cNvPr id="4" name="text">
             <a:extLst xmlns:a="http://schemas.openxmlformats.org/drawingml/2006/main">
               <a:ext uri="{FF2B5EF4-FFF2-40B4-BE49-F238E27FC236}">
-                <a16:creationId xmlns:a16="http://schemas.microsoft.com/office/drawing/2014/main" id="{3D4FCE0C-8F37-4BF3-B04A-60B041D206E7}"/>
+                <a16:creationId xmlns:a16="http://schemas.microsoft.com/office/drawing/2014/main" id="{2A9FB539-3815-4AB1-8D9C-E12A9DA0EDFE}"/>
               </a:ext>
             </a:extLst>
           </p:cNvPr>
@@ -14317,7 +14266,7 @@
           <p:cNvPr id="5" name="text">
             <a:extLst xmlns:a="http://schemas.openxmlformats.org/drawingml/2006/main">
               <a:ext uri="{FF2B5EF4-FFF2-40B4-BE49-F238E27FC236}">
-                <a16:creationId xmlns:a16="http://schemas.microsoft.com/office/drawing/2014/main" id="{2B5F5633-6C70-4249-AA15-812ECC8E0858}"/>
+                <a16:creationId xmlns:a16="http://schemas.microsoft.com/office/drawing/2014/main" id="{7F4C448B-3A3A-4920-AFF9-E2F42209B2D9}"/>
               </a:ext>
             </a:extLst>
           </p:cNvPr>
@@ -14374,7 +14323,7 @@
           <p:cNvPr id="6" name="text">
             <a:extLst xmlns:a="http://schemas.openxmlformats.org/drawingml/2006/main">
               <a:ext uri="{FF2B5EF4-FFF2-40B4-BE49-F238E27FC236}">
-                <a16:creationId xmlns:a16="http://schemas.microsoft.com/office/drawing/2014/main" id="{2B8ADAEB-175A-4DCB-8E51-2AE254BC2E9C}"/>
+                <a16:creationId xmlns:a16="http://schemas.microsoft.com/office/drawing/2014/main" id="{D6CB9FA8-D908-44E6-96D9-C842EE9CBFAF}"/>
               </a:ext>
             </a:extLst>
           </p:cNvPr>
@@ -14431,7 +14380,7 @@
           <p:cNvPr id="7" name="text">
             <a:extLst xmlns:a="http://schemas.openxmlformats.org/drawingml/2006/main">
               <a:ext uri="{FF2B5EF4-FFF2-40B4-BE49-F238E27FC236}">
-                <a16:creationId xmlns:a16="http://schemas.microsoft.com/office/drawing/2014/main" id="{FF4223FF-3B32-4FAF-9EB5-261869C67C4F}"/>
+                <a16:creationId xmlns:a16="http://schemas.microsoft.com/office/drawing/2014/main" id="{A502CC4F-B125-4AC9-BFF5-E292C811E86C}"/>
               </a:ext>
             </a:extLst>
           </p:cNvPr>
@@ -14488,7 +14437,7 @@
           <p:cNvPr id="8" name="text">
             <a:extLst xmlns:a="http://schemas.openxmlformats.org/drawingml/2006/main">
               <a:ext uri="{FF2B5EF4-FFF2-40B4-BE49-F238E27FC236}">
-                <a16:creationId xmlns:a16="http://schemas.microsoft.com/office/drawing/2014/main" id="{59E51484-B204-4E44-95A1-301424C10EB4}"/>
+                <a16:creationId xmlns:a16="http://schemas.microsoft.com/office/drawing/2014/main" id="{DC8319C9-2685-4F1C-9D21-1F11AA117377}"/>
               </a:ext>
             </a:extLst>
           </p:cNvPr>
@@ -14545,7 +14494,7 @@
           <p:cNvPr id="9" name="text">
             <a:extLst xmlns:a="http://schemas.openxmlformats.org/drawingml/2006/main">
               <a:ext uri="{FF2B5EF4-FFF2-40B4-BE49-F238E27FC236}">
-                <a16:creationId xmlns:a16="http://schemas.microsoft.com/office/drawing/2014/main" id="{F5C264D5-07CA-41C5-AAAD-5E241F60A69E}"/>
+                <a16:creationId xmlns:a16="http://schemas.microsoft.com/office/drawing/2014/main" id="{0EC3C7E0-99BC-4FBD-97F1-4A0001624A36}"/>
               </a:ext>
             </a:extLst>
           </p:cNvPr>
@@ -14602,7 +14551,7 @@
           <p:cNvPr id="10" name="text">
             <a:extLst xmlns:a="http://schemas.openxmlformats.org/drawingml/2006/main">
               <a:ext uri="{FF2B5EF4-FFF2-40B4-BE49-F238E27FC236}">
-                <a16:creationId xmlns:a16="http://schemas.microsoft.com/office/drawing/2014/main" id="{D785B611-CD71-4781-AA34-0DC370BB9E8C}"/>
+                <a16:creationId xmlns:a16="http://schemas.microsoft.com/office/drawing/2014/main" id="{0DA948EC-530B-48BE-8727-C1564C80533B}"/>
               </a:ext>
             </a:extLst>
           </p:cNvPr>
@@ -14657,7 +14606,7 @@
     </p:spTree>
     <p:extLst>
       <p:ext uri="{BB962C8B-B14F-4D97-AF65-F5344CB8AC3E}">
-        <p14:creationId xmlns:p14="http://schemas.microsoft.com/office/powerpoint/2010/main" val="1394685178"/>
+        <p14:creationId xmlns:p14="http://schemas.microsoft.com/office/powerpoint/2010/main" val="23353857"/>
       </p:ext>
     </p:extLst>
   </p:cSld>
@@ -14688,7 +14637,7 @@
           <p:cNvPr id="11" name="course">
             <a:extLst xmlns:a="http://schemas.openxmlformats.org/drawingml/2006/main">
               <a:ext uri="{FF2B5EF4-FFF2-40B4-BE49-F238E27FC236}">
-                <a16:creationId xmlns:a16="http://schemas.microsoft.com/office/drawing/2014/main" id="{4FB77A0A-203F-4122-9EEC-1502D9193618}"/>
+                <a16:creationId xmlns:a16="http://schemas.microsoft.com/office/drawing/2014/main" id="{3F8DF515-DC0B-40B9-989E-E43F186D2D18}"/>
               </a:ext>
             </a:extLst>
           </p:cNvPr>
@@ -14745,7 +14694,7 @@
           <p:cNvPr id="2" name="title">
             <a:extLst xmlns:a="http://schemas.openxmlformats.org/drawingml/2006/main">
               <a:ext uri="{FF2B5EF4-FFF2-40B4-BE49-F238E27FC236}">
-                <a16:creationId xmlns:a16="http://schemas.microsoft.com/office/drawing/2014/main" id="{B76652DB-E482-4D4B-AA25-23EC35039FAC}"/>
+                <a16:creationId xmlns:a16="http://schemas.microsoft.com/office/drawing/2014/main" id="{80FFB6B8-0D52-4903-8CF5-676F69142EF3}"/>
               </a:ext>
             </a:extLst>
           </p:cNvPr>
@@ -14802,7 +14751,7 @@
           <p:cNvPr id="3" name="page">
             <a:extLst xmlns:a="http://schemas.openxmlformats.org/drawingml/2006/main">
               <a:ext uri="{FF2B5EF4-FFF2-40B4-BE49-F238E27FC236}">
-                <a16:creationId xmlns:a16="http://schemas.microsoft.com/office/drawing/2014/main" id="{B2DD60B1-0FA7-42A1-A87D-859820EC3EC7}"/>
+                <a16:creationId xmlns:a16="http://schemas.microsoft.com/office/drawing/2014/main" id="{BA6196B4-CECE-45BB-AA7F-A0B1FB3C9038}"/>
               </a:ext>
             </a:extLst>
           </p:cNvPr>
@@ -14859,7 +14808,7 @@
           <p:cNvPr id="4" name="text">
             <a:extLst xmlns:a="http://schemas.openxmlformats.org/drawingml/2006/main">
               <a:ext uri="{FF2B5EF4-FFF2-40B4-BE49-F238E27FC236}">
-                <a16:creationId xmlns:a16="http://schemas.microsoft.com/office/drawing/2014/main" id="{77A3D9B4-ED0B-44D1-A162-66E0C26264BA}"/>
+                <a16:creationId xmlns:a16="http://schemas.microsoft.com/office/drawing/2014/main" id="{76B16583-D4D7-4C86-A7A8-EDC29EFBDC7D}"/>
               </a:ext>
             </a:extLst>
           </p:cNvPr>
@@ -14916,7 +14865,7 @@
           <p:cNvPr id="5" name="text">
             <a:extLst xmlns:a="http://schemas.openxmlformats.org/drawingml/2006/main">
               <a:ext uri="{FF2B5EF4-FFF2-40B4-BE49-F238E27FC236}">
-                <a16:creationId xmlns:a16="http://schemas.microsoft.com/office/drawing/2014/main" id="{B40FD066-374D-4AD5-B950-0A251C57402F}"/>
+                <a16:creationId xmlns:a16="http://schemas.microsoft.com/office/drawing/2014/main" id="{73E565E0-B34D-4331-B380-1921C8AB76E3}"/>
               </a:ext>
             </a:extLst>
           </p:cNvPr>
@@ -14973,7 +14922,7 @@
           <p:cNvPr id="6" name="text">
             <a:extLst xmlns:a="http://schemas.openxmlformats.org/drawingml/2006/main">
               <a:ext uri="{FF2B5EF4-FFF2-40B4-BE49-F238E27FC236}">
-                <a16:creationId xmlns:a16="http://schemas.microsoft.com/office/drawing/2014/main" id="{0EC26BB8-E994-4C32-B470-B0E25A1FEA65}"/>
+                <a16:creationId xmlns:a16="http://schemas.microsoft.com/office/drawing/2014/main" id="{CB355C99-AD91-44EC-8AC4-7BC4256B7FDD}"/>
               </a:ext>
             </a:extLst>
           </p:cNvPr>
@@ -15030,7 +14979,7 @@
           <p:cNvPr id="7" name="text">
             <a:extLst xmlns:a="http://schemas.openxmlformats.org/drawingml/2006/main">
               <a:ext uri="{FF2B5EF4-FFF2-40B4-BE49-F238E27FC236}">
-                <a16:creationId xmlns:a16="http://schemas.microsoft.com/office/drawing/2014/main" id="{6D1A3546-B380-4BA7-A8FA-54C2F77C5538}"/>
+                <a16:creationId xmlns:a16="http://schemas.microsoft.com/office/drawing/2014/main" id="{8BD262CA-AB6D-49B4-B410-899DED45189C}"/>
               </a:ext>
             </a:extLst>
           </p:cNvPr>
@@ -15087,7 +15036,7 @@
           <p:cNvPr id="8" name="text">
             <a:extLst xmlns:a="http://schemas.openxmlformats.org/drawingml/2006/main">
               <a:ext uri="{FF2B5EF4-FFF2-40B4-BE49-F238E27FC236}">
-                <a16:creationId xmlns:a16="http://schemas.microsoft.com/office/drawing/2014/main" id="{947BCD1A-AF23-4708-8DF7-04AB8EC5BD20}"/>
+                <a16:creationId xmlns:a16="http://schemas.microsoft.com/office/drawing/2014/main" id="{40CA00EC-D815-4652-9AE9-DEF2FBC45450}"/>
               </a:ext>
             </a:extLst>
           </p:cNvPr>
@@ -15144,7 +15093,7 @@
           <p:cNvPr id="9" name="text">
             <a:extLst xmlns:a="http://schemas.openxmlformats.org/drawingml/2006/main">
               <a:ext uri="{FF2B5EF4-FFF2-40B4-BE49-F238E27FC236}">
-                <a16:creationId xmlns:a16="http://schemas.microsoft.com/office/drawing/2014/main" id="{56F78E88-4E23-4281-B636-A6106214ECC5}"/>
+                <a16:creationId xmlns:a16="http://schemas.microsoft.com/office/drawing/2014/main" id="{93DB729B-67A9-42A5-9A84-FE984C7D1FFB}"/>
               </a:ext>
             </a:extLst>
           </p:cNvPr>
@@ -15201,7 +15150,7 @@
           <p:cNvPr id="10" name="text">
             <a:extLst xmlns:a="http://schemas.openxmlformats.org/drawingml/2006/main">
               <a:ext uri="{FF2B5EF4-FFF2-40B4-BE49-F238E27FC236}">
-                <a16:creationId xmlns:a16="http://schemas.microsoft.com/office/drawing/2014/main" id="{18A32870-F3CA-40D4-B90C-A05F59A2DBFE}"/>
+                <a16:creationId xmlns:a16="http://schemas.microsoft.com/office/drawing/2014/main" id="{F10FDB56-E0BF-4AE0-A4F1-B7CACBD53DB5}"/>
               </a:ext>
             </a:extLst>
           </p:cNvPr>
@@ -15256,7 +15205,7 @@
     </p:spTree>
     <p:extLst>
       <p:ext uri="{BB962C8B-B14F-4D97-AF65-F5344CB8AC3E}">
-        <p14:creationId xmlns:p14="http://schemas.microsoft.com/office/powerpoint/2010/main" val="199426630"/>
+        <p14:creationId xmlns:p14="http://schemas.microsoft.com/office/powerpoint/2010/main" val="2028152262"/>
       </p:ext>
     </p:extLst>
   </p:cSld>

</xml_diff>